<commit_message>
SV1 results, N=7/8 angles, README, slides with real numbers
- Run solution.ipynb end to end on aws:aws:sim:sv1 (10 jobs, IDs in results/jobs.json)
- Finish N=7 and N=8 angle tuning (tune_angles.py now resumes from saved angles)
- Add README with team, results table, job IDs and AI use note
- Slides: team names, 3-speaker notes, SV1 column, numbers from summary.json
- Remove HANDOFF.md

Co-Authored-By: Claude Opus 5.5 <noreply@anthropic.com>
</commit_message>
<xml_diff>
--- a/slides.pptx
+++ b/slides.pptx
@@ -118,7 +118,7 @@
 <c:chartSpace xmlns:c="http://schemas.openxmlformats.org/drawingml/2006/chart" xmlns:a="http://schemas.openxmlformats.org/drawingml/2006/main" xmlns:r="http://schemas.openxmlformats.org/officeDocument/2006/relationships">
   <c:date1904 val="0"/>
   <c:chart>
-    <c:autoTitleDeleted val="0"/>
+    <c:autoTitleDeleted val="1"/>
     <c:plotArea>
       <c:lineChart>
         <c:grouping val="standard"/>
@@ -203,40 +203,40 @@
                 <c:formatCode>General</c:formatCode>
                 <c:ptCount val="12"/>
                 <c:pt idx="0">
-                  <c:v>0.010961662038328138</c:v>
+                  <c:v>0.010956797062765046</c:v>
                 </c:pt>
                 <c:pt idx="1">
-                  <c:v>0.027401945239748336</c:v>
+                  <c:v>0.02738264033988491</c:v>
                 </c:pt>
                 <c:pt idx="2">
-                  <c:v>0.04770083253530374</c:v>
+                  <c:v>0.047695289998323655</c:v>
                 </c:pt>
                 <c:pt idx="3">
-                  <c:v>0.08809578866580607</c:v>
+                  <c:v>0.08809603625645926</c:v>
                 </c:pt>
                 <c:pt idx="4">
-                  <c:v>0.14180562348913517</c:v>
+                  <c:v>0.14184200152100823</c:v>
                 </c:pt>
                 <c:pt idx="5">
-                  <c:v>0.21142390693470475</c:v>
+                  <c:v>0.2113435942587491</c:v>
                 </c:pt>
                 <c:pt idx="6">
-                  <c:v>0.3219245775427265</c:v>
+                  <c:v>0.32074272777074336</c:v>
                 </c:pt>
                 <c:pt idx="7">
-                  <c:v>0.4179890042658713</c:v>
+                  <c:v>0.41789390003074395</c:v>
                 </c:pt>
                 <c:pt idx="8">
-                  <c:v>0.5013215613506805</c:v>
+                  <c:v>0.5014502142448615</c:v>
                 </c:pt>
                 <c:pt idx="9">
-                  <c:v>0.5787952599097943</c:v>
+                  <c:v>0.579284222454486</c:v>
                 </c:pt>
                 <c:pt idx="10">
-                  <c:v>0.6593606021241409</c:v>
+                  <c:v>0.6595587835969536</c:v>
                 </c:pt>
                 <c:pt idx="11">
-                  <c:v>0.7287012047228751</c:v>
+                  <c:v>0.7288901699283823</c:v>
                 </c:pt>
               </c:numCache>
             </c:numRef>
@@ -363,7 +363,7 @@
 <c:chartSpace xmlns:c="http://schemas.openxmlformats.org/drawingml/2006/chart" xmlns:a="http://schemas.openxmlformats.org/drawingml/2006/main" xmlns:r="http://schemas.openxmlformats.org/officeDocument/2006/relationships">
   <c:date1904 val="0"/>
   <c:chart>
-    <c:autoTitleDeleted val="0"/>
+    <c:autoTitleDeleted val="1"/>
     <c:plotArea>
       <c:lineChart>
         <c:grouping val="standard"/>
@@ -399,9 +399,9 @@
           </c:marker>
           <c:cat>
             <c:strRef>
-              <c:f>Sheet1!$A$2:$A$4</c:f>
+              <c:f>Sheet1!$A$2:$A$6</c:f>
               <c:strCache>
-                <c:ptCount val="3"/>
+                <c:ptCount val="5"/>
                 <c:pt idx="0">
                   <c:v>4</c:v>
                 </c:pt>
@@ -411,15 +411,21 @@
                 <c:pt idx="2">
                   <c:v>6</c:v>
                 </c:pt>
+                <c:pt idx="3">
+                  <c:v>7</c:v>
+                </c:pt>
+                <c:pt idx="4">
+                  <c:v>8</c:v>
+                </c:pt>
               </c:strCache>
             </c:strRef>
           </c:cat>
           <c:val>
             <c:numRef>
-              <c:f>Sheet1!$B$2:$B$4</c:f>
+              <c:f>Sheet1!$B$2:$B$6</c:f>
               <c:numCache>
                 <c:formatCode>General</c:formatCode>
-                <c:ptCount val="3"/>
+                <c:ptCount val="5"/>
                 <c:pt idx="0">
                   <c:v>0.5787952599097943</c:v>
                 </c:pt>
@@ -428,6 +434,12 @@
                 </c:pt>
                 <c:pt idx="2">
                   <c:v>0.09456350094970882</c:v>
+                </c:pt>
+                <c:pt idx="3">
+                  <c:v>0.03484286082799597</c:v>
+                </c:pt>
+                <c:pt idx="4">
+                  <c:v>0.042934894629718424</c:v>
                 </c:pt>
               </c:numCache>
             </c:numRef>
@@ -465,9 +477,9 @@
           </c:marker>
           <c:cat>
             <c:strRef>
-              <c:f>Sheet1!$A$2:$A$4</c:f>
+              <c:f>Sheet1!$A$2:$A$6</c:f>
               <c:strCache>
-                <c:ptCount val="3"/>
+                <c:ptCount val="5"/>
                 <c:pt idx="0">
                   <c:v>4</c:v>
                 </c:pt>
@@ -477,15 +489,21 @@
                 <c:pt idx="2">
                   <c:v>6</c:v>
                 </c:pt>
+                <c:pt idx="3">
+                  <c:v>7</c:v>
+                </c:pt>
+                <c:pt idx="4">
+                  <c:v>8</c:v>
+                </c:pt>
               </c:strCache>
             </c:strRef>
           </c:cat>
           <c:val>
             <c:numRef>
-              <c:f>Sheet1!$C$2:$C$4</c:f>
+              <c:f>Sheet1!$C$2:$C$6</c:f>
               <c:numCache>
                 <c:formatCode>General</c:formatCode>
-                <c:ptCount val="3"/>
+                <c:ptCount val="5"/>
                 <c:pt idx="0">
                   <c:v>0.0015432098765432098</c:v>
                 </c:pt>
@@ -494,6 +512,12 @@
                 </c:pt>
                 <c:pt idx="2">
                   <c:v>4.286694101508916e-05</c:v>
+                </c:pt>
+                <c:pt idx="3">
+                  <c:v>7.144490169181527e-06</c:v>
+                </c:pt>
+                <c:pt idx="4">
+                  <c:v>1.1907483615302546e-06</c:v>
                 </c:pt>
               </c:numCache>
             </c:numRef>
@@ -578,7 +602,7 @@
           <c:layout/>
           <c:overlay val="0"/>
         </c:title>
-        <c:numFmt formatCode="0.0000%" sourceLinked="0"/>
+        <c:numFmt formatCode="0.000%" sourceLinked="0"/>
         <c:majorTickMark val="out"/>
         <c:minorTickMark val="none"/>
         <c:tickLblPos val="nextTo"/>
@@ -1156,7 +1180,7 @@
           <a:lstStyle/>
           <a:p>
             <a:r>
-              <a:t>Speaker 2: bit order — qubit 0 is the rightmost character in a Qiskit key; cube 1 is the last 3 characters. We tested the decoder on the known answer.</a:t>
+              <a:t>Speaker 1: bit order — qubit 0 is the rightmost character in a Qiskit key; cube 1 is the last 3 characters. We tested the decoder on the known answer.</a:t>
             </a:r>
           </a:p>
         </p:txBody>
@@ -1296,7 +1320,7 @@
           <a:lstStyle/>
           <a:p>
             <a:r>
-              <a:t>Speaker 3: this is the slide for the tie-break criterion. Say how each check would catch a bug.</a:t>
+              <a:t>Speaker 2: this is the slide for the tie-break criterion. Say how each check would catch a bug.</a:t>
             </a:r>
           </a:p>
         </p:txBody>
@@ -1366,7 +1390,7 @@
           <a:lstStyle/>
           <a:p>
             <a:r>
-              <a:t>Speaker 3: the line is the exact simulation; the table is shots. Point out the baseline and that no shot was an illegal code.</a:t>
+              <a:t>Speaker 2: the line is the exact simulation; the table is shots. Point out the baseline and that no shot was an illegal code.</a:t>
             </a:r>
           </a:p>
         </p:txBody>
@@ -1436,7 +1460,7 @@
           <a:lstStyle/>
           <a:p>
             <a:r>
-              <a:t>Speaker 4: angles for N=5-8 were tuned offline with the same function and reloaded; the notebook recomputes their success. N=7,8 local shots come from the exact distribution unless run on SV1.</a:t>
+              <a:t>Speaker 3: angles for N=5-8 were tuned offline with the same function and reloaded; the notebook recomputes their success. N=7,8 local shots come from the exact distribution unless run on SV1.</a:t>
             </a:r>
           </a:p>
         </p:txBody>
@@ -1506,7 +1530,7 @@
           <a:lstStyle/>
           <a:p>
             <a:r>
-              <a:t>Speaker 4: close with honesty — what works, what doesn't scale, and the one next experiment.</a:t>
+              <a:t>Speaker 3: close with honesty — what works, what doesn't scale, and the one next experiment.</a:t>
             </a:r>
           </a:p>
         </p:txBody>
@@ -4804,7 +4828,7 @@
                 </a:solidFill>
                 <a:latin typeface="Calibri"/>
               </a:rPr>
-              <a:t>Team: [add names]</a:t>
+              <a:t>Team: Zain Irfan, Mark Gebuza, Rithwik Mohanty</a:t>
             </a:r>
           </a:p>
           <a:p>
@@ -5336,7 +5360,7 @@
         <p:spPr>
           <a:xfrm>
             <a:off x="4480560" y="1737360"/>
-            <a:ext cx="7040880" cy="4480560"/>
+            <a:ext cx="7040880" cy="3931920"/>
           </a:xfrm>
           <a:prstGeom prst="roundRect">
             <a:avLst>
@@ -7934,7 +7958,7 @@
                 </a:solidFill>
                 <a:latin typeface="Calibri"/>
               </a:rPr>
-              <a:t>on all 1,296 valid states (N ≤ 6: all states; N = 7, 8: 3,000 random). Largest gap 0.</a:t>
+              <a:t>N = 4 to 6: every valid state; N = 7, 8: 3,000 random ones. Largest gap 0.</a:t>
             </a:r>
           </a:p>
         </p:txBody>
@@ -8387,7 +8411,7 @@
                 </a:solidFill>
                 <a:latin typeface="Calibri"/>
               </a:rPr>
-              <a:t>start state is 1/6 on each valid code; leakage to codes 6, 7 is 7e-15; 0 invalid shots.</a:t>
+              <a:t>start state is 1/6 on each valid code; leakage to codes 6, 7 is 2e-15; 0 invalid shots.</a:t>
             </a:r>
           </a:p>
         </p:txBody>
@@ -8538,7 +8562,7 @@
                 </a:solidFill>
                 <a:latin typeface="Calibri"/>
               </a:rPr>
-              <a:t>our 6^N simulator matches Statevector of the real circuit to 5e-17.</a:t>
+              <a:t>our 6^N simulator matches Statevector of the real circuit to 3e-17.</a:t>
             </a:r>
           </a:p>
         </p:txBody>
@@ -8918,7 +8942,7 @@
                 </a:solidFill>
                 <a:latin typeface="Cambria"/>
               </a:rPr>
-              <a:t>Four cubes: 70% of shots are the solved tower</a:t>
+              <a:t>Four cubes: 73% of shots are the solved tower</a:t>
             </a:r>
           </a:p>
         </p:txBody>
@@ -9084,7 +9108,7 @@
                           </a:solidFill>
                           <a:latin typeface="Calibri"/>
                         </a:rPr>
-                        <a:t>measured</a:t>
+                        <a:t>SV1</a:t>
                       </a:r>
                     </a:p>
                   </a:txBody>
@@ -9196,7 +9220,7 @@
                           </a:solidFill>
                           <a:latin typeface="Calibri"/>
                         </a:rPr>
-                        <a:t>1.1%</a:t>
+                        <a:t>1.7%</a:t>
                       </a:r>
                     </a:p>
                   </a:txBody>
@@ -9308,7 +9332,7 @@
                           </a:solidFill>
                           <a:latin typeface="Calibri"/>
                         </a:rPr>
-                        <a:t>8.5%</a:t>
+                        <a:t>8.7%</a:t>
                       </a:r>
                     </a:p>
                   </a:txBody>
@@ -9420,7 +9444,7 @@
                           </a:solidFill>
                           <a:latin typeface="Calibri"/>
                         </a:rPr>
-                        <a:t>39%</a:t>
+                        <a:t>42%</a:t>
                       </a:r>
                     </a:p>
                   </a:txBody>
@@ -9532,7 +9556,7 @@
                           </a:solidFill>
                           <a:latin typeface="Calibri"/>
                         </a:rPr>
-                        <a:t>70%</a:t>
+                        <a:t>73%</a:t>
                       </a:r>
                     </a:p>
                   </a:txBody>
@@ -9612,7 +9636,7 @@
                 </a:solidFill>
                 <a:latin typeface="Calibri"/>
               </a:rPr>
-              <a:t>local Aer (SV1 pending)</a:t>
+              <a:t>aws:aws:sim:sv1</a:t>
             </a:r>
           </a:p>
           <a:p>
@@ -9628,7 +9652,7 @@
                 </a:solidFill>
                 <a:latin typeface="Calibri"/>
               </a:rPr>
-              <a:t>p = 12 is about 456× a random legal guess. </a:t>
+              <a:t>Measured at p = 12: about 475× a random legal guess. </a:t>
             </a:r>
             <a:r>
               <a:rPr sz="1400" b="0" i="0">
@@ -9662,7 +9686,7 @@
                 </a:solidFill>
                 <a:latin typeface="Calibri"/>
               </a:rPr>
-              <a:t>28% good picks at p = 2.</a:t>
+              <a:t>31% good picks at p = 2.</a:t>
             </a:r>
           </a:p>
         </p:txBody>
@@ -9972,13 +9996,14 @@
                 <a:tableStyleId>{5C22544A-7EE6-4342-B048-85BDC9FD1C3A}</a:tableStyleId>
               </a:tblPr>
               <a:tblGrid>
-                <a:gridCol w="932688"/>
-                <a:gridCol w="932688"/>
-                <a:gridCol w="932688"/>
-                <a:gridCol w="932688"/>
-                <a:gridCol w="932688"/>
+                <a:gridCol w="777240"/>
+                <a:gridCol w="777240"/>
+                <a:gridCol w="777240"/>
+                <a:gridCol w="777240"/>
+                <a:gridCol w="777240"/>
+                <a:gridCol w="777240"/>
               </a:tblGrid>
-              <a:tr h="685800">
+              <a:tr h="457200">
                 <a:tc>
                   <a:txBody>
                     <a:bodyPr/>
@@ -10057,7 +10082,29 @@
                           </a:solidFill>
                           <a:latin typeface="Calibri"/>
                         </a:rPr>
-                        <a:t>P(correct)</a:t>
+                        <a:t>exact</a:t>
+                      </a:r>
+                    </a:p>
+                  </a:txBody>
+                  <a:tcPr>
+                    <a:solidFill>
+                      <a:srgbClr val="0E9488"/>
+                    </a:solidFill>
+                  </a:tcPr>
+                </a:tc>
+                <a:tc>
+                  <a:txBody>
+                    <a:bodyPr/>
+                    <a:lstStyle/>
+                    <a:p>
+                      <a:r>
+                        <a:rPr sz="1300" b="1">
+                          <a:solidFill>
+                            <a:srgbClr val="FFFFFF"/>
+                          </a:solidFill>
+                          <a:latin typeface="Calibri"/>
+                        </a:rPr>
+                        <a:t>SV1 shots</a:t>
                       </a:r>
                     </a:p>
                   </a:txBody>
@@ -10090,7 +10137,7 @@
                   </a:tcPr>
                 </a:tc>
               </a:tr>
-              <a:tr h="685800">
+              <a:tr h="457200">
                 <a:tc>
                   <a:txBody>
                     <a:bodyPr/>
@@ -10191,6 +10238,28 @@
                           </a:solidFill>
                           <a:latin typeface="Calibri"/>
                         </a:rPr>
+                        <a:t>59%</a:t>
+                      </a:r>
+                    </a:p>
+                  </a:txBody>
+                  <a:tcPr>
+                    <a:solidFill>
+                      <a:srgbClr val="E8F4F3"/>
+                    </a:solidFill>
+                  </a:tcPr>
+                </a:tc>
+                <a:tc>
+                  <a:txBody>
+                    <a:bodyPr/>
+                    <a:lstStyle/>
+                    <a:p>
+                      <a:r>
+                        <a:rPr sz="1300" b="0">
+                          <a:solidFill>
+                            <a:srgbClr val="1B2433"/>
+                          </a:solidFill>
+                          <a:latin typeface="Calibri"/>
+                        </a:rPr>
                         <a:t>375</a:t>
                       </a:r>
                     </a:p>
@@ -10202,7 +10271,7 @@
                   </a:tcPr>
                 </a:tc>
               </a:tr>
-              <a:tr h="685800">
+              <a:tr h="457200">
                 <a:tc>
                   <a:txBody>
                     <a:bodyPr/>
@@ -10303,6 +10372,28 @@
                           </a:solidFill>
                           <a:latin typeface="Calibri"/>
                         </a:rPr>
+                        <a:t>9.5%</a:t>
+                      </a:r>
+                    </a:p>
+                  </a:txBody>
+                  <a:tcPr>
+                    <a:solidFill>
+                      <a:srgbClr val="FFFFFF"/>
+                    </a:solidFill>
+                  </a:tcPr>
+                </a:tc>
+                <a:tc>
+                  <a:txBody>
+                    <a:bodyPr/>
+                    <a:lstStyle/>
+                    <a:p>
+                      <a:r>
+                        <a:rPr sz="1300" b="0">
+                          <a:solidFill>
+                            <a:srgbClr val="1B2433"/>
+                          </a:solidFill>
+                          <a:latin typeface="Calibri"/>
+                        </a:rPr>
                         <a:t>354</a:t>
                       </a:r>
                     </a:p>
@@ -10314,7 +10405,7 @@
                   </a:tcPr>
                 </a:tc>
               </a:tr>
-              <a:tr h="685800">
+              <a:tr h="457200">
                 <a:tc>
                   <a:txBody>
                     <a:bodyPr/>
@@ -10415,7 +10506,297 @@
                           </a:solidFill>
                           <a:latin typeface="Calibri"/>
                         </a:rPr>
+                        <a:t>9.4%</a:t>
+                      </a:r>
+                    </a:p>
+                  </a:txBody>
+                  <a:tcPr>
+                    <a:solidFill>
+                      <a:srgbClr val="E8F4F3"/>
+                    </a:solidFill>
+                  </a:tcPr>
+                </a:tc>
+                <a:tc>
+                  <a:txBody>
+                    <a:bodyPr/>
+                    <a:lstStyle/>
+                    <a:p>
+                      <a:r>
+                        <a:rPr sz="1300" b="0">
+                          <a:solidFill>
+                            <a:srgbClr val="1B2433"/>
+                          </a:solidFill>
+                          <a:latin typeface="Calibri"/>
+                        </a:rPr>
                         <a:t>2,206</a:t>
+                      </a:r>
+                    </a:p>
+                  </a:txBody>
+                  <a:tcPr>
+                    <a:solidFill>
+                      <a:srgbClr val="E8F4F3"/>
+                    </a:solidFill>
+                  </a:tcPr>
+                </a:tc>
+              </a:tr>
+              <a:tr h="457200">
+                <a:tc>
+                  <a:txBody>
+                    <a:bodyPr/>
+                    <a:lstStyle/>
+                    <a:p>
+                      <a:r>
+                        <a:rPr sz="1300" b="0">
+                          <a:solidFill>
+                            <a:srgbClr val="1B2433"/>
+                          </a:solidFill>
+                          <a:latin typeface="Calibri"/>
+                        </a:rPr>
+                        <a:t>7</a:t>
+                      </a:r>
+                    </a:p>
+                  </a:txBody>
+                  <a:tcPr>
+                    <a:solidFill>
+                      <a:srgbClr val="FFFFFF"/>
+                    </a:solidFill>
+                  </a:tcPr>
+                </a:tc>
+                <a:tc>
+                  <a:txBody>
+                    <a:bodyPr/>
+                    <a:lstStyle/>
+                    <a:p>
+                      <a:r>
+                        <a:rPr sz="1300" b="0">
+                          <a:solidFill>
+                            <a:srgbClr val="1B2433"/>
+                          </a:solidFill>
+                          <a:latin typeface="Calibri"/>
+                        </a:rPr>
+                        <a:t>21</a:t>
+                      </a:r>
+                    </a:p>
+                  </a:txBody>
+                  <a:tcPr>
+                    <a:solidFill>
+                      <a:srgbClr val="FFFFFF"/>
+                    </a:solidFill>
+                  </a:tcPr>
+                </a:tc>
+                <a:tc>
+                  <a:txBody>
+                    <a:bodyPr/>
+                    <a:lstStyle/>
+                    <a:p>
+                      <a:r>
+                        <a:rPr sz="1300" b="0">
+                          <a:solidFill>
+                            <a:srgbClr val="1B2433"/>
+                          </a:solidFill>
+                          <a:latin typeface="Calibri"/>
+                        </a:rPr>
+                        <a:t>16,627</a:t>
+                      </a:r>
+                    </a:p>
+                  </a:txBody>
+                  <a:tcPr>
+                    <a:solidFill>
+                      <a:srgbClr val="FFFFFF"/>
+                    </a:solidFill>
+                  </a:tcPr>
+                </a:tc>
+                <a:tc>
+                  <a:txBody>
+                    <a:bodyPr/>
+                    <a:lstStyle/>
+                    <a:p>
+                      <a:r>
+                        <a:rPr sz="1300" b="0">
+                          <a:solidFill>
+                            <a:srgbClr val="1B2433"/>
+                          </a:solidFill>
+                          <a:latin typeface="Calibri"/>
+                        </a:rPr>
+                        <a:t>3.5%</a:t>
+                      </a:r>
+                    </a:p>
+                  </a:txBody>
+                  <a:tcPr>
+                    <a:solidFill>
+                      <a:srgbClr val="FFFFFF"/>
+                    </a:solidFill>
+                  </a:tcPr>
+                </a:tc>
+                <a:tc>
+                  <a:txBody>
+                    <a:bodyPr/>
+                    <a:lstStyle/>
+                    <a:p>
+                      <a:r>
+                        <a:rPr sz="1300" b="0">
+                          <a:solidFill>
+                            <a:srgbClr val="1B2433"/>
+                          </a:solidFill>
+                          <a:latin typeface="Calibri"/>
+                        </a:rPr>
+                        <a:t>3.3%</a:t>
+                      </a:r>
+                    </a:p>
+                  </a:txBody>
+                  <a:tcPr>
+                    <a:solidFill>
+                      <a:srgbClr val="FFFFFF"/>
+                    </a:solidFill>
+                  </a:tcPr>
+                </a:tc>
+                <a:tc>
+                  <a:txBody>
+                    <a:bodyPr/>
+                    <a:lstStyle/>
+                    <a:p>
+                      <a:r>
+                        <a:rPr sz="1300" b="0">
+                          <a:solidFill>
+                            <a:srgbClr val="1B2433"/>
+                          </a:solidFill>
+                          <a:latin typeface="Calibri"/>
+                        </a:rPr>
+                        <a:t>4,877</a:t>
+                      </a:r>
+                    </a:p>
+                  </a:txBody>
+                  <a:tcPr>
+                    <a:solidFill>
+                      <a:srgbClr val="FFFFFF"/>
+                    </a:solidFill>
+                  </a:tcPr>
+                </a:tc>
+              </a:tr>
+              <a:tr h="457200">
+                <a:tc>
+                  <a:txBody>
+                    <a:bodyPr/>
+                    <a:lstStyle/>
+                    <a:p>
+                      <a:r>
+                        <a:rPr sz="1300" b="0">
+                          <a:solidFill>
+                            <a:srgbClr val="1B2433"/>
+                          </a:solidFill>
+                          <a:latin typeface="Calibri"/>
+                        </a:rPr>
+                        <a:t>8</a:t>
+                      </a:r>
+                    </a:p>
+                  </a:txBody>
+                  <a:tcPr>
+                    <a:solidFill>
+                      <a:srgbClr val="E8F4F3"/>
+                    </a:solidFill>
+                  </a:tcPr>
+                </a:tc>
+                <a:tc>
+                  <a:txBody>
+                    <a:bodyPr/>
+                    <a:lstStyle/>
+                    <a:p>
+                      <a:r>
+                        <a:rPr sz="1300" b="0">
+                          <a:solidFill>
+                            <a:srgbClr val="1B2433"/>
+                          </a:solidFill>
+                          <a:latin typeface="Calibri"/>
+                        </a:rPr>
+                        <a:t>24</a:t>
+                      </a:r>
+                    </a:p>
+                  </a:txBody>
+                  <a:tcPr>
+                    <a:solidFill>
+                      <a:srgbClr val="E8F4F3"/>
+                    </a:solidFill>
+                  </a:tcPr>
+                </a:tc>
+                <a:tc>
+                  <a:txBody>
+                    <a:bodyPr/>
+                    <a:lstStyle/>
+                    <a:p>
+                      <a:r>
+                        <a:rPr sz="1300" b="0">
+                          <a:solidFill>
+                            <a:srgbClr val="1B2433"/>
+                          </a:solidFill>
+                          <a:latin typeface="Calibri"/>
+                        </a:rPr>
+                        <a:t>21,128</a:t>
+                      </a:r>
+                    </a:p>
+                  </a:txBody>
+                  <a:tcPr>
+                    <a:solidFill>
+                      <a:srgbClr val="E8F4F3"/>
+                    </a:solidFill>
+                  </a:tcPr>
+                </a:tc>
+                <a:tc>
+                  <a:txBody>
+                    <a:bodyPr/>
+                    <a:lstStyle/>
+                    <a:p>
+                      <a:r>
+                        <a:rPr sz="1300" b="0">
+                          <a:solidFill>
+                            <a:srgbClr val="1B2433"/>
+                          </a:solidFill>
+                          <a:latin typeface="Calibri"/>
+                        </a:rPr>
+                        <a:t>4.3%</a:t>
+                      </a:r>
+                    </a:p>
+                  </a:txBody>
+                  <a:tcPr>
+                    <a:solidFill>
+                      <a:srgbClr val="E8F4F3"/>
+                    </a:solidFill>
+                  </a:tcPr>
+                </a:tc>
+                <a:tc>
+                  <a:txBody>
+                    <a:bodyPr/>
+                    <a:lstStyle/>
+                    <a:p>
+                      <a:r>
+                        <a:rPr sz="1300" b="0">
+                          <a:solidFill>
+                            <a:srgbClr val="1B2433"/>
+                          </a:solidFill>
+                          <a:latin typeface="Calibri"/>
+                        </a:rPr>
+                        <a:t>3.3%</a:t>
+                      </a:r>
+                    </a:p>
+                  </a:txBody>
+                  <a:tcPr>
+                    <a:solidFill>
+                      <a:srgbClr val="E8F4F3"/>
+                    </a:solidFill>
+                  </a:tcPr>
+                </a:tc>
+                <a:tc>
+                  <a:txBody>
+                    <a:bodyPr/>
+                    <a:lstStyle/>
+                    <a:p>
+                      <a:r>
+                        <a:rPr sz="1300" b="0">
+                          <a:solidFill>
+                            <a:srgbClr val="1B2433"/>
+                          </a:solidFill>
+                          <a:latin typeface="Calibri"/>
+                        </a:rPr>
+                        <a:t>36,057</a:t>
                       </a:r>
                     </a:p>
                   </a:txBody>

</xml_diff>

<commit_message>
Slides: fix log-axis labels on the bonus chart
Co-Authored-By: Claude Opus 5.5 <noreply@anthropic.com>
</commit_message>
<xml_diff>
--- a/slides.pptx
+++ b/slides.pptx
@@ -558,9 +558,9 @@
         </c:title>
         <c:majorTickMark val="out"/>
         <c:minorTickMark val="none"/>
-        <c:tickLblPos val="nextTo"/>
+        <c:tickLblPos val="low"/>
         <c:crossAx val="2140495176"/>
-        <c:crosses val="autoZero"/>
+        <c:crosses val="min"/>
         <c:auto val="1"/>
         <c:lblAlgn val="ctr"/>
         <c:lblOffset val="100"/>
@@ -602,7 +602,7 @@
           <c:layout/>
           <c:overlay val="0"/>
         </c:title>
-        <c:numFmt formatCode="0.000%" sourceLinked="0"/>
+        <c:numFmt formatCode="[&gt;=0.01]0%;[&gt;=0.00001]0.0##%;0.0000%" sourceLinked="0"/>
         <c:majorTickMark val="out"/>
         <c:minorTickMark val="none"/>
         <c:tickLblPos val="nextTo"/>

</xml_diff>

<commit_message>
Slides: add cube nets, solved tower and colour-graph figures
Slide 2 shows the four cubes unfolded, the solved tower and the colour graph;
slide 3 highlights the answer's front/back and left/right picks on the graph.
Figures are drawn with the starter's helpers by build_slides.py.

Co-Authored-By: Claude Opus 5.5 <noreply@anthropic.com>
</commit_message>
<xml_diff>
--- a/slides.pptx
+++ b/slides.pptx
@@ -5125,8 +5125,134 @@
         </p:nvSpPr>
         <p:spPr>
           <a:xfrm>
-            <a:off x="731520" y="1737360"/>
-            <a:ext cx="3291840" cy="822960"/>
+            <a:off x="731520" y="1508760"/>
+            <a:ext cx="7315200" cy="365760"/>
+          </a:xfrm>
+          <a:prstGeom prst="rect">
+            <a:avLst/>
+          </a:prstGeom>
+          <a:noFill/>
+        </p:spPr>
+        <p:txBody>
+          <a:bodyPr wrap="square" anchor="t" lIns="0" rIns="0">
+            <a:spAutoFit/>
+          </a:bodyPr>
+          <a:lstStyle/>
+          <a:p>
+            <a:pPr algn="l">
+              <a:spcAft>
+                <a:spcPts val="600"/>
+              </a:spcAft>
+            </a:pPr>
+            <a:r>
+              <a:rPr sz="1300" b="1" i="0">
+                <a:solidFill>
+                  <a:srgbClr val="5B6575"/>
+                </a:solidFill>
+                <a:latin typeface="Calibri"/>
+              </a:rPr>
+              <a:t>The four cubes, unfolded</a:t>
+            </a:r>
+          </a:p>
+        </p:txBody>
+      </p:sp>
+      <p:pic>
+        <p:nvPicPr>
+          <p:cNvPr id="9" name="Picture 8" descr="fig_nets.png"/>
+          <p:cNvPicPr>
+            <a:picLocks noChangeAspect="1"/>
+          </p:cNvPicPr>
+          <p:nvPr/>
+        </p:nvPicPr>
+        <p:blipFill>
+          <a:blip r:embed="rId2"/>
+          <a:stretch>
+            <a:fillRect/>
+          </a:stretch>
+        </p:blipFill>
+        <p:spPr>
+          <a:xfrm>
+            <a:off x="731520" y="1828800"/>
+            <a:ext cx="7315200" cy="1523262"/>
+          </a:xfrm>
+          <a:prstGeom prst="rect">
+            <a:avLst/>
+          </a:prstGeom>
+        </p:spPr>
+      </p:pic>
+      <p:sp>
+        <p:nvSpPr>
+          <p:cNvPr id="10" name="TextBox 9"/>
+          <p:cNvSpPr txBox="1"/>
+          <p:nvPr/>
+        </p:nvSpPr>
+        <p:spPr>
+          <a:xfrm>
+            <a:off x="8869680" y="1508760"/>
+            <a:ext cx="2743200" cy="365760"/>
+          </a:xfrm>
+          <a:prstGeom prst="rect">
+            <a:avLst/>
+          </a:prstGeom>
+          <a:noFill/>
+        </p:spPr>
+        <p:txBody>
+          <a:bodyPr wrap="square" anchor="t" lIns="0" rIns="0">
+            <a:spAutoFit/>
+          </a:bodyPr>
+          <a:lstStyle/>
+          <a:p>
+            <a:pPr algn="l">
+              <a:spcAft>
+                <a:spcPts val="600"/>
+              </a:spcAft>
+            </a:pPr>
+            <a:r>
+              <a:rPr sz="1300" b="1" i="0">
+                <a:solidFill>
+                  <a:srgbClr val="5B6575"/>
+                </a:solidFill>
+                <a:latin typeface="Calibri"/>
+              </a:rPr>
+              <a:t>The one solved tower</a:t>
+            </a:r>
+          </a:p>
+        </p:txBody>
+      </p:sp>
+      <p:pic>
+        <p:nvPicPr>
+          <p:cNvPr id="11" name="Picture 10" descr="fig_tower.png"/>
+          <p:cNvPicPr>
+            <a:picLocks noChangeAspect="1"/>
+          </p:cNvPicPr>
+          <p:nvPr/>
+        </p:nvPicPr>
+        <p:blipFill>
+          <a:blip r:embed="rId3"/>
+          <a:stretch>
+            <a:fillRect/>
+          </a:stretch>
+        </p:blipFill>
+        <p:spPr>
+          <a:xfrm>
+            <a:off x="8961120" y="1828800"/>
+            <a:ext cx="1914290" cy="1874519"/>
+          </a:xfrm>
+          <a:prstGeom prst="rect">
+            <a:avLst/>
+          </a:prstGeom>
+        </p:spPr>
+      </p:pic>
+      <p:sp>
+        <p:nvSpPr>
+          <p:cNvPr id="12" name="TextBox 11"/>
+          <p:cNvSpPr txBox="1"/>
+          <p:nvPr/>
+        </p:nvSpPr>
+        <p:spPr>
+          <a:xfrm>
+            <a:off x="731520" y="3977639"/>
+            <a:ext cx="2743200" cy="822960"/>
           </a:xfrm>
           <a:prstGeom prst="rect">
             <a:avLst/>
@@ -5158,14 +5284,14 @@
       </p:sp>
       <p:sp>
         <p:nvSpPr>
-          <p:cNvPr id="9" name="TextBox 8"/>
+          <p:cNvPr id="13" name="TextBox 12"/>
           <p:cNvSpPr txBox="1"/>
           <p:nvPr/>
         </p:nvSpPr>
         <p:spPr>
           <a:xfrm>
-            <a:off x="731520" y="2514600"/>
-            <a:ext cx="3291840" cy="640080"/>
+            <a:off x="731520" y="4754879"/>
+            <a:ext cx="2743200" cy="640080"/>
           </a:xfrm>
           <a:prstGeom prst="rect">
             <a:avLst/>
@@ -5190,21 +5316,21 @@
                 </a:solidFill>
                 <a:latin typeface="Calibri"/>
               </a:rPr>
-              <a:t>ways to stack 4 cubes (24 orientations each)</a:t>
-            </a:r>
-          </a:p>
-        </p:txBody>
-      </p:sp>
-      <p:sp>
-        <p:nvSpPr>
-          <p:cNvPr id="10" name="TextBox 9"/>
+              <a:t>ways to stack 4 cubes</a:t>
+            </a:r>
+          </a:p>
+        </p:txBody>
+      </p:sp>
+      <p:sp>
+        <p:nvSpPr>
+          <p:cNvPr id="14" name="TextBox 13"/>
           <p:cNvSpPr txBox="1"/>
           <p:nvPr/>
         </p:nvSpPr>
         <p:spPr>
           <a:xfrm>
-            <a:off x="731520" y="3200400"/>
-            <a:ext cx="3291840" cy="822960"/>
+            <a:off x="3657600" y="3977639"/>
+            <a:ext cx="2103120" cy="822960"/>
           </a:xfrm>
           <a:prstGeom prst="rect">
             <a:avLst/>
@@ -5236,14 +5362,14 @@
       </p:sp>
       <p:sp>
         <p:nvSpPr>
-          <p:cNvPr id="11" name="TextBox 10"/>
+          <p:cNvPr id="15" name="TextBox 14"/>
           <p:cNvSpPr txBox="1"/>
           <p:nvPr/>
         </p:nvSpPr>
         <p:spPr>
           <a:xfrm>
-            <a:off x="731520" y="3977639"/>
-            <a:ext cx="3291840" cy="640080"/>
+            <a:off x="3657600" y="4754879"/>
+            <a:ext cx="2103120" cy="640080"/>
           </a:xfrm>
           <a:prstGeom prst="rect">
             <a:avLst/>
@@ -5268,21 +5394,21 @@
                 </a:solidFill>
                 <a:latin typeface="Calibri"/>
               </a:rPr>
-              <a:t>solved: one tower seen from 8 angles</a:t>
-            </a:r>
-          </a:p>
-        </p:txBody>
-      </p:sp>
-      <p:sp>
-        <p:nvSpPr>
-          <p:cNvPr id="12" name="TextBox 11"/>
+              <a:t>solved: one tower, 8 views</a:t>
+            </a:r>
+          </a:p>
+        </p:txBody>
+      </p:sp>
+      <p:sp>
+        <p:nvSpPr>
+          <p:cNvPr id="16" name="TextBox 15"/>
           <p:cNvSpPr txBox="1"/>
           <p:nvPr/>
         </p:nvSpPr>
         <p:spPr>
           <a:xfrm>
-            <a:off x="731520" y="4663440"/>
-            <a:ext cx="3291840" cy="822960"/>
+            <a:off x="5760720" y="3977639"/>
+            <a:ext cx="2103120" cy="822960"/>
           </a:xfrm>
           <a:prstGeom prst="rect">
             <a:avLst/>
@@ -5314,14 +5440,14 @@
       </p:sp>
       <p:sp>
         <p:nvSpPr>
-          <p:cNvPr id="13" name="TextBox 12"/>
+          <p:cNvPr id="17" name="TextBox 16"/>
           <p:cNvSpPr txBox="1"/>
           <p:nvPr/>
         </p:nvSpPr>
         <p:spPr>
           <a:xfrm>
-            <a:off x="731520" y="5440679"/>
-            <a:ext cx="3291840" cy="640080"/>
+            <a:off x="5760720" y="4754879"/>
+            <a:ext cx="2103120" cy="640080"/>
           </a:xfrm>
           <a:prstGeom prst="rect">
             <a:avLst/>
@@ -5346,21 +5472,108 @@
                 </a:solidFill>
                 <a:latin typeface="Calibri"/>
               </a:rPr>
-              <a:t>for classical brute force to find them</a:t>
-            </a:r>
-          </a:p>
-        </p:txBody>
-      </p:sp>
-      <p:sp>
-        <p:nvSpPr>
-          <p:cNvPr id="14" name="Rounded Rectangle 13"/>
+              <a:t>classical brute force</a:t>
+            </a:r>
+          </a:p>
+        </p:txBody>
+      </p:sp>
+      <p:sp>
+        <p:nvSpPr>
+          <p:cNvPr id="18" name="TextBox 17"/>
+          <p:cNvSpPr txBox="1"/>
+          <p:nvPr/>
+        </p:nvSpPr>
+        <p:spPr>
+          <a:xfrm>
+            <a:off x="731520" y="5669280"/>
+            <a:ext cx="6949440" cy="822960"/>
+          </a:xfrm>
+          <a:prstGeom prst="rect">
+            <a:avLst/>
+          </a:prstGeom>
+          <a:noFill/>
+        </p:spPr>
+        <p:txBody>
+          <a:bodyPr wrap="square" anchor="t" lIns="0" rIns="0">
+            <a:spAutoFit/>
+          </a:bodyPr>
+          <a:lstStyle/>
+          <a:p>
+            <a:pPr algn="l">
+              <a:spcAft>
+                <a:spcPts val="600"/>
+              </a:spcAft>
+            </a:pPr>
+            <a:r>
+              <a:rPr sz="1400" b="0" i="1">
+                <a:solidFill>
+                  <a:srgbClr val="5B6575"/>
+                </a:solidFill>
+                <a:latin typeface="Calibri"/>
+              </a:rPr>
+              <a:t>The general N-cube problem is NP-complete. </a:t>
+            </a:r>
+            <a:r>
+              <a:rPr sz="1400" b="0" i="1">
+                <a:solidFill>
+                  <a:srgbClr val="5B6575"/>
+                </a:solidFill>
+                <a:latin typeface="Calibri"/>
+              </a:rPr>
+              <a:t>We do not claim a speedup.</a:t>
+            </a:r>
+          </a:p>
+        </p:txBody>
+      </p:sp>
+      <p:sp>
+        <p:nvSpPr>
+          <p:cNvPr id="19" name="TextBox 18"/>
+          <p:cNvSpPr txBox="1"/>
+          <p:nvPr/>
+        </p:nvSpPr>
+        <p:spPr>
+          <a:xfrm>
+            <a:off x="7955279" y="3840480"/>
+            <a:ext cx="3840480" cy="365760"/>
+          </a:xfrm>
+          <a:prstGeom prst="rect">
+            <a:avLst/>
+          </a:prstGeom>
+          <a:noFill/>
+        </p:spPr>
+        <p:txBody>
+          <a:bodyPr wrap="square" anchor="t" lIns="0" rIns="0">
+            <a:spAutoFit/>
+          </a:bodyPr>
+          <a:lstStyle/>
+          <a:p>
+            <a:pPr algn="l">
+              <a:spcAft>
+                <a:spcPts val="600"/>
+              </a:spcAft>
+            </a:pPr>
+            <a:r>
+              <a:rPr sz="1200" b="1" i="0">
+                <a:solidFill>
+                  <a:srgbClr val="5B6575"/>
+                </a:solidFill>
+                <a:latin typeface="Calibri"/>
+              </a:rPr>
+              <a:t>Graph view: colours are dots, opposite pairs are lines</a:t>
+            </a:r>
+          </a:p>
+        </p:txBody>
+      </p:sp>
+      <p:sp>
+        <p:nvSpPr>
+          <p:cNvPr id="20" name="Rounded Rectangle 19"/>
           <p:cNvSpPr/>
           <p:nvPr/>
         </p:nvSpPr>
         <p:spPr>
           <a:xfrm>
-            <a:off x="4480560" y="1737360"/>
-            <a:ext cx="7040880" cy="3931920"/>
+            <a:off x="7955279" y="4206240"/>
+            <a:ext cx="3657600" cy="2377440"/>
           </a:xfrm>
           <a:prstGeom prst="roundRect">
             <a:avLst>
@@ -5396,161 +5609,30 @@
           </a:p>
         </p:txBody>
       </p:sp>
-      <p:sp>
-        <p:nvSpPr>
-          <p:cNvPr id="15" name="TextBox 14"/>
-          <p:cNvSpPr txBox="1"/>
+      <p:pic>
+        <p:nvPicPr>
+          <p:cNvPr id="21" name="Picture 20" descr="fig_graph.png"/>
+          <p:cNvPicPr>
+            <a:picLocks noChangeAspect="1"/>
+          </p:cNvPicPr>
           <p:nvPr/>
-        </p:nvSpPr>
-        <p:spPr>
-          <a:xfrm>
-            <a:off x="4800600" y="1965960"/>
-            <a:ext cx="6492240" cy="4114800"/>
+        </p:nvPicPr>
+        <p:blipFill>
+          <a:blip r:embed="rId4"/>
+          <a:stretch>
+            <a:fillRect/>
+          </a:stretch>
+        </p:blipFill>
+        <p:spPr>
+          <a:xfrm>
+            <a:off x="8092440" y="4297680"/>
+            <a:ext cx="2885440" cy="2194560"/>
           </a:xfrm>
           <a:prstGeom prst="rect">
             <a:avLst/>
           </a:prstGeom>
-          <a:noFill/>
-        </p:spPr>
-        <p:txBody>
-          <a:bodyPr wrap="square" anchor="t" lIns="0" rIns="0">
-            <a:spAutoFit/>
-          </a:bodyPr>
-          <a:lstStyle/>
-          <a:p>
-            <a:pPr algn="l">
-              <a:spcAft>
-                <a:spcPts val="1000"/>
-              </a:spcAft>
-            </a:pPr>
-            <a:r>
-              <a:rPr sz="2000" b="1" i="0">
-                <a:solidFill>
-                  <a:srgbClr val="1B2433"/>
-                </a:solidFill>
-                <a:latin typeface="Cambria"/>
-              </a:rPr>
-              <a:t>Graph view</a:t>
-            </a:r>
-          </a:p>
-          <a:p>
-            <a:pPr algn="l">
-              <a:spcAft>
-                <a:spcPts val="1000"/>
-              </a:spcAft>
-            </a:pPr>
-            <a:r>
-              <a:rPr sz="1700" b="0" i="0">
-                <a:solidFill>
-                  <a:srgbClr val="1B2433"/>
-                </a:solidFill>
-                <a:latin typeface="Calibri"/>
-              </a:rPr>
-              <a:t>Colours are nodes; each cube's 3 opposite-face pairs are edges.</a:t>
-            </a:r>
-          </a:p>
-          <a:p>
-            <a:pPr algn="l">
-              <a:spcAft>
-                <a:spcPts val="1000"/>
-              </a:spcAft>
-            </a:pPr>
-            <a:r>
-              <a:rPr sz="1700" b="0" i="0">
-                <a:solidFill>
-                  <a:srgbClr val="1B2433"/>
-                </a:solidFill>
-                <a:latin typeface="Calibri"/>
-              </a:rPr>
-              <a:t>Front/back picks must touch every colour exactly twice (a 2-factor). So must the left/right picks, using a different pair of the same cube.</a:t>
-            </a:r>
-          </a:p>
-          <a:p>
-            <a:pPr algn="l">
-              <a:spcAft>
-                <a:spcPts val="1000"/>
-              </a:spcAft>
-            </a:pPr>
-            <a:r>
-              <a:rPr sz="1700" b="0" i="0">
-                <a:solidFill>
-                  <a:srgbClr val="1B2433"/>
-                </a:solidFill>
-                <a:latin typeface="Calibri"/>
-              </a:rPr>
-              <a:t>So each cube has only </a:t>
-            </a:r>
-            <a:r>
-              <a:rPr sz="1700" b="1" i="0">
-                <a:solidFill>
-                  <a:srgbClr val="1B2433"/>
-                </a:solidFill>
-                <a:latin typeface="Calibri"/>
-              </a:rPr>
-              <a:t>6 choices</a:t>
-            </a:r>
-            <a:r>
-              <a:rPr sz="1700" b="0" i="0">
-                <a:solidFill>
-                  <a:srgbClr val="1B2433"/>
-                </a:solidFill>
-                <a:latin typeface="Calibri"/>
-              </a:rPr>
-              <a:t>: an ordered pair (front/back pair, left/right pair).</a:t>
-            </a:r>
-          </a:p>
-          <a:p>
-            <a:pPr algn="l">
-              <a:spcAft>
-                <a:spcPts val="1000"/>
-              </a:spcAft>
-            </a:pPr>
-            <a:r>
-              <a:rPr sz="1700" b="0" i="0">
-                <a:solidFill>
-                  <a:srgbClr val="1B2433"/>
-                </a:solidFill>
-                <a:latin typeface="Calibri"/>
-              </a:rPr>
-              <a:t>6⁴ = 1,296 cases, of which </a:t>
-            </a:r>
-            <a:r>
-              <a:rPr sz="1700" b="1" i="0">
-                <a:solidFill>
-                  <a:srgbClr val="1B2433"/>
-                </a:solidFill>
-                <a:latin typeface="Calibri"/>
-              </a:rPr>
-              <a:t>2</a:t>
-            </a:r>
-            <a:r>
-              <a:rPr sz="1700" b="0" i="0">
-                <a:solidFill>
-                  <a:srgbClr val="1B2433"/>
-                </a:solidFill>
-                <a:latin typeface="Calibri"/>
-              </a:rPr>
-              <a:t> solve it (the tower and its quarter turn).</a:t>
-            </a:r>
-          </a:p>
-          <a:p>
-            <a:pPr algn="l">
-              <a:spcAft>
-                <a:spcPts val="1000"/>
-              </a:spcAft>
-            </a:pPr>
-            <a:r>
-              <a:rPr sz="1700" b="0" i="1">
-                <a:solidFill>
-                  <a:srgbClr val="5B6575"/>
-                </a:solidFill>
-                <a:latin typeface="Calibri"/>
-              </a:rPr>
-              <a:t>The general N-cube problem is NP-complete. We do not claim a speedup.</a:t>
-            </a:r>
-          </a:p>
-        </p:txBody>
-      </p:sp>
+        </p:spPr>
+      </p:pic>
     </p:spTree>
   </p:cSld>
   <p:clrMapOvr>
@@ -5775,7 +5857,7 @@
                 </a:solidFill>
                 <a:latin typeface="Cambria"/>
               </a:rPr>
-              <a:t>Encoding: 6 choices fit in 3 qubits</a:t>
+              <a:t>The trick: 6 choices per cube fit in 3 qubits</a:t>
             </a:r>
           </a:p>
         </p:txBody>
@@ -5814,22 +5896,70 @@
                 </a:solidFill>
                 <a:latin typeface="Calibri"/>
               </a:rPr>
-              <a:t>12 qubits for 4 cubes, half the starter's 24-qubit one-hot encoding</a:t>
-            </a:r>
-          </a:p>
-        </p:txBody>
-      </p:sp>
+              <a:t>Colours are dots, opposite-face pairs are lines. The answer's picks touch every colour exactly twice</a:t>
+            </a:r>
+          </a:p>
+        </p:txBody>
+      </p:sp>
+      <p:pic>
+        <p:nvPicPr>
+          <p:cNvPr id="8" name="Picture 7" descr="fig_graph_fb.png"/>
+          <p:cNvPicPr>
+            <a:picLocks noChangeAspect="1"/>
+          </p:cNvPicPr>
+          <p:nvPr/>
+        </p:nvPicPr>
+        <p:blipFill>
+          <a:blip r:embed="rId2"/>
+          <a:stretch>
+            <a:fillRect/>
+          </a:stretch>
+        </p:blipFill>
+        <p:spPr>
+          <a:xfrm>
+            <a:off x="548640" y="1600200"/>
+            <a:ext cx="2881445" cy="2331720"/>
+          </a:xfrm>
+          <a:prstGeom prst="rect">
+            <a:avLst/>
+          </a:prstGeom>
+        </p:spPr>
+      </p:pic>
+      <p:pic>
+        <p:nvPicPr>
+          <p:cNvPr id="9" name="Picture 8" descr="fig_graph_lr.png"/>
+          <p:cNvPicPr>
+            <a:picLocks noChangeAspect="1"/>
+          </p:cNvPicPr>
+          <p:nvPr/>
+        </p:nvPicPr>
+        <p:blipFill>
+          <a:blip r:embed="rId3"/>
+          <a:stretch>
+            <a:fillRect/>
+          </a:stretch>
+        </p:blipFill>
+        <p:spPr>
+          <a:xfrm>
+            <a:off x="548640" y="4023360"/>
+            <a:ext cx="2881445" cy="2331720"/>
+          </a:xfrm>
+          <a:prstGeom prst="rect">
+            <a:avLst/>
+          </a:prstGeom>
+        </p:spPr>
+      </p:pic>
       <p:graphicFrame>
         <p:nvGraphicFramePr>
-          <p:cNvPr id="8" name="Table 7"/>
+          <p:cNvPr id="10" name="Table 9"/>
           <p:cNvGraphicFramePr>
             <a:graphicFrameLocks noGrp="1"/>
           </p:cNvGraphicFramePr>
           <p:nvPr/>
         </p:nvGraphicFramePr>
         <p:xfrm>
-          <a:off x="731520" y="1737360"/>
-          <a:ext cx="5120640" cy="4206240"/>
+          <a:off x="4343400" y="1783080"/>
+          <a:ext cx="3566160" cy="3840480"/>
         </p:xfrm>
         <a:graphic>
           <a:graphicData uri="http://schemas.openxmlformats.org/drawingml/2006/table">
@@ -5838,19 +5968,19 @@
                 <a:tableStyleId>{5C22544A-7EE6-4342-B048-85BDC9FD1C3A}</a:tableStyleId>
               </a:tblPr>
               <a:tblGrid>
-                <a:gridCol w="1280160"/>
-                <a:gridCol w="1280160"/>
-                <a:gridCol w="1280160"/>
-                <a:gridCol w="1280160"/>
+                <a:gridCol w="594360"/>
+                <a:gridCol w="685800"/>
+                <a:gridCol w="1143000"/>
+                <a:gridCol w="1143000"/>
               </a:tblGrid>
-              <a:tr h="525780">
+              <a:tr h="480060">
                 <a:tc>
                   <a:txBody>
                     <a:bodyPr/>
                     <a:lstStyle/>
                     <a:p>
                       <a:r>
-                        <a:rPr sz="1500" b="1">
+                        <a:rPr sz="1300" b="1">
                           <a:solidFill>
                             <a:srgbClr val="FFFFFF"/>
                           </a:solidFill>
@@ -5872,7 +6002,7 @@
                     <a:lstStyle/>
                     <a:p>
                       <a:r>
-                        <a:rPr sz="1500" b="1">
+                        <a:rPr sz="1300" b="1">
                           <a:solidFill>
                             <a:srgbClr val="FFFFFF"/>
                           </a:solidFill>
@@ -5894,7 +6024,7 @@
                     <a:lstStyle/>
                     <a:p>
                       <a:r>
-                        <a:rPr sz="1500" b="1">
+                        <a:rPr sz="1300" b="1">
                           <a:solidFill>
                             <a:srgbClr val="FFFFFF"/>
                           </a:solidFill>
@@ -5916,7 +6046,7 @@
                     <a:lstStyle/>
                     <a:p>
                       <a:r>
-                        <a:rPr sz="1500" b="1">
+                        <a:rPr sz="1300" b="1">
                           <a:solidFill>
                             <a:srgbClr val="FFFFFF"/>
                           </a:solidFill>
@@ -5933,14 +6063,14 @@
                   </a:tcPr>
                 </a:tc>
               </a:tr>
-              <a:tr h="525780">
+              <a:tr h="480060">
                 <a:tc>
                   <a:txBody>
                     <a:bodyPr/>
                     <a:lstStyle/>
                     <a:p>
                       <a:r>
-                        <a:rPr sz="1500" b="0">
+                        <a:rPr sz="1300" b="0">
                           <a:solidFill>
                             <a:srgbClr val="1B2433"/>
                           </a:solidFill>
@@ -5962,7 +6092,7 @@
                     <a:lstStyle/>
                     <a:p>
                       <a:r>
-                        <a:rPr sz="1500" b="0">
+                        <a:rPr sz="1300" b="0">
                           <a:solidFill>
                             <a:srgbClr val="1B2433"/>
                           </a:solidFill>
@@ -5984,7 +6114,7 @@
                     <a:lstStyle/>
                     <a:p>
                       <a:r>
-                        <a:rPr sz="1500" b="0">
+                        <a:rPr sz="1300" b="0">
                           <a:solidFill>
                             <a:srgbClr val="1B2433"/>
                           </a:solidFill>
@@ -6006,7 +6136,7 @@
                     <a:lstStyle/>
                     <a:p>
                       <a:r>
-                        <a:rPr sz="1500" b="0">
+                        <a:rPr sz="1300" b="0">
                           <a:solidFill>
                             <a:srgbClr val="1B2433"/>
                           </a:solidFill>
@@ -6023,14 +6153,14 @@
                   </a:tcPr>
                 </a:tc>
               </a:tr>
-              <a:tr h="525780">
+              <a:tr h="480060">
                 <a:tc>
                   <a:txBody>
                     <a:bodyPr/>
                     <a:lstStyle/>
                     <a:p>
                       <a:r>
-                        <a:rPr sz="1500" b="0">
+                        <a:rPr sz="1300" b="0">
                           <a:solidFill>
                             <a:srgbClr val="1B2433"/>
                           </a:solidFill>
@@ -6052,7 +6182,7 @@
                     <a:lstStyle/>
                     <a:p>
                       <a:r>
-                        <a:rPr sz="1500" b="0">
+                        <a:rPr sz="1300" b="0">
                           <a:solidFill>
                             <a:srgbClr val="1B2433"/>
                           </a:solidFill>
@@ -6074,7 +6204,7 @@
                     <a:lstStyle/>
                     <a:p>
                       <a:r>
-                        <a:rPr sz="1500" b="0">
+                        <a:rPr sz="1300" b="0">
                           <a:solidFill>
                             <a:srgbClr val="1B2433"/>
                           </a:solidFill>
@@ -6096,7 +6226,7 @@
                     <a:lstStyle/>
                     <a:p>
                       <a:r>
-                        <a:rPr sz="1500" b="0">
+                        <a:rPr sz="1300" b="0">
                           <a:solidFill>
                             <a:srgbClr val="1B2433"/>
                           </a:solidFill>
@@ -6113,14 +6243,14 @@
                   </a:tcPr>
                 </a:tc>
               </a:tr>
-              <a:tr h="525780">
+              <a:tr h="480060">
                 <a:tc>
                   <a:txBody>
                     <a:bodyPr/>
                     <a:lstStyle/>
                     <a:p>
                       <a:r>
-                        <a:rPr sz="1500" b="0">
+                        <a:rPr sz="1300" b="0">
                           <a:solidFill>
                             <a:srgbClr val="1B2433"/>
                           </a:solidFill>
@@ -6142,7 +6272,7 @@
                     <a:lstStyle/>
                     <a:p>
                       <a:r>
-                        <a:rPr sz="1500" b="0">
+                        <a:rPr sz="1300" b="0">
                           <a:solidFill>
                             <a:srgbClr val="1B2433"/>
                           </a:solidFill>
@@ -6164,7 +6294,7 @@
                     <a:lstStyle/>
                     <a:p>
                       <a:r>
-                        <a:rPr sz="1500" b="0">
+                        <a:rPr sz="1300" b="0">
                           <a:solidFill>
                             <a:srgbClr val="1B2433"/>
                           </a:solidFill>
@@ -6186,7 +6316,7 @@
                     <a:lstStyle/>
                     <a:p>
                       <a:r>
-                        <a:rPr sz="1500" b="0">
+                        <a:rPr sz="1300" b="0">
                           <a:solidFill>
                             <a:srgbClr val="1B2433"/>
                           </a:solidFill>
@@ -6203,14 +6333,14 @@
                   </a:tcPr>
                 </a:tc>
               </a:tr>
-              <a:tr h="525780">
+              <a:tr h="480060">
                 <a:tc>
                   <a:txBody>
                     <a:bodyPr/>
                     <a:lstStyle/>
                     <a:p>
                       <a:r>
-                        <a:rPr sz="1500" b="0">
+                        <a:rPr sz="1300" b="0">
                           <a:solidFill>
                             <a:srgbClr val="1B2433"/>
                           </a:solidFill>
@@ -6232,7 +6362,7 @@
                     <a:lstStyle/>
                     <a:p>
                       <a:r>
-                        <a:rPr sz="1500" b="0">
+                        <a:rPr sz="1300" b="0">
                           <a:solidFill>
                             <a:srgbClr val="1B2433"/>
                           </a:solidFill>
@@ -6254,7 +6384,7 @@
                     <a:lstStyle/>
                     <a:p>
                       <a:r>
-                        <a:rPr sz="1500" b="0">
+                        <a:rPr sz="1300" b="0">
                           <a:solidFill>
                             <a:srgbClr val="1B2433"/>
                           </a:solidFill>
@@ -6276,7 +6406,7 @@
                     <a:lstStyle/>
                     <a:p>
                       <a:r>
-                        <a:rPr sz="1500" b="0">
+                        <a:rPr sz="1300" b="0">
                           <a:solidFill>
                             <a:srgbClr val="1B2433"/>
                           </a:solidFill>
@@ -6293,14 +6423,14 @@
                   </a:tcPr>
                 </a:tc>
               </a:tr>
-              <a:tr h="525780">
+              <a:tr h="480060">
                 <a:tc>
                   <a:txBody>
                     <a:bodyPr/>
                     <a:lstStyle/>
                     <a:p>
                       <a:r>
-                        <a:rPr sz="1500" b="0">
+                        <a:rPr sz="1300" b="0">
                           <a:solidFill>
                             <a:srgbClr val="1B2433"/>
                           </a:solidFill>
@@ -6322,7 +6452,7 @@
                     <a:lstStyle/>
                     <a:p>
                       <a:r>
-                        <a:rPr sz="1500" b="0">
+                        <a:rPr sz="1300" b="0">
                           <a:solidFill>
                             <a:srgbClr val="1B2433"/>
                           </a:solidFill>
@@ -6344,7 +6474,7 @@
                     <a:lstStyle/>
                     <a:p>
                       <a:r>
-                        <a:rPr sz="1500" b="0">
+                        <a:rPr sz="1300" b="0">
                           <a:solidFill>
                             <a:srgbClr val="1B2433"/>
                           </a:solidFill>
@@ -6366,7 +6496,7 @@
                     <a:lstStyle/>
                     <a:p>
                       <a:r>
-                        <a:rPr sz="1500" b="0">
+                        <a:rPr sz="1300" b="0">
                           <a:solidFill>
                             <a:srgbClr val="1B2433"/>
                           </a:solidFill>
@@ -6383,14 +6513,14 @@
                   </a:tcPr>
                 </a:tc>
               </a:tr>
-              <a:tr h="525780">
+              <a:tr h="480060">
                 <a:tc>
                   <a:txBody>
                     <a:bodyPr/>
                     <a:lstStyle/>
                     <a:p>
                       <a:r>
-                        <a:rPr sz="1500" b="0">
+                        <a:rPr sz="1300" b="0">
                           <a:solidFill>
                             <a:srgbClr val="1B2433"/>
                           </a:solidFill>
@@ -6412,7 +6542,7 @@
                     <a:lstStyle/>
                     <a:p>
                       <a:r>
-                        <a:rPr sz="1500" b="0">
+                        <a:rPr sz="1300" b="0">
                           <a:solidFill>
                             <a:srgbClr val="1B2433"/>
                           </a:solidFill>
@@ -6434,7 +6564,7 @@
                     <a:lstStyle/>
                     <a:p>
                       <a:r>
-                        <a:rPr sz="1500" b="0">
+                        <a:rPr sz="1300" b="0">
                           <a:solidFill>
                             <a:srgbClr val="1B2433"/>
                           </a:solidFill>
@@ -6456,7 +6586,7 @@
                     <a:lstStyle/>
                     <a:p>
                       <a:r>
-                        <a:rPr sz="1500" b="0">
+                        <a:rPr sz="1300" b="0">
                           <a:solidFill>
                             <a:srgbClr val="1B2433"/>
                           </a:solidFill>
@@ -6473,14 +6603,14 @@
                   </a:tcPr>
                 </a:tc>
               </a:tr>
-              <a:tr h="525780">
+              <a:tr h="480060">
                 <a:tc>
                   <a:txBody>
                     <a:bodyPr/>
                     <a:lstStyle/>
                     <a:p>
                       <a:r>
-                        <a:rPr sz="1500" b="0">
+                        <a:rPr sz="1300" b="0">
                           <a:solidFill>
                             <a:srgbClr val="1B2433"/>
                           </a:solidFill>
@@ -6502,7 +6632,7 @@
                     <a:lstStyle/>
                     <a:p>
                       <a:r>
-                        <a:rPr sz="1500" b="0">
+                        <a:rPr sz="1300" b="0">
                           <a:solidFill>
                             <a:srgbClr val="1B2433"/>
                           </a:solidFill>
@@ -6524,7 +6654,7 @@
                     <a:lstStyle/>
                     <a:p>
                       <a:r>
-                        <a:rPr sz="1500" b="0">
+                        <a:rPr sz="1300" b="0">
                           <a:solidFill>
                             <a:srgbClr val="1B2433"/>
                           </a:solidFill>
@@ -6546,13 +6676,13 @@
                     <a:lstStyle/>
                     <a:p>
                       <a:r>
-                        <a:rPr sz="1500" b="0">
+                        <a:rPr sz="1300" b="0">
                           <a:solidFill>
                             <a:srgbClr val="1B2433"/>
                           </a:solidFill>
                           <a:latin typeface="Calibri"/>
                         </a:rPr>
-                        <a:t>never reached</a:t>
+                        <a:t>never</a:t>
                       </a:r>
                     </a:p>
                   </a:txBody>
@@ -6569,14 +6699,14 @@
       </p:graphicFrame>
       <p:sp>
         <p:nvSpPr>
-          <p:cNvPr id="9" name="TextBox 8"/>
+          <p:cNvPr id="11" name="TextBox 10"/>
           <p:cNvSpPr txBox="1"/>
           <p:nvPr/>
         </p:nvSpPr>
         <p:spPr>
           <a:xfrm>
-            <a:off x="6400800" y="1737360"/>
-            <a:ext cx="5120640" cy="4389120"/>
+            <a:off x="8229600" y="1783080"/>
+            <a:ext cx="3474720" cy="4754880"/>
           </a:xfrm>
           <a:prstGeom prst="rect">
             <a:avLst/>
@@ -6591,86 +6721,95 @@
           <a:p>
             <a:pPr algn="l">
               <a:spcAft>
-                <a:spcPts val="1200"/>
+                <a:spcPts val="900"/>
               </a:spcAft>
             </a:pPr>
             <a:r>
-              <a:rPr sz="1700" b="1" i="0">
+              <a:rPr sz="1400" b="1" i="0">
                 <a:solidFill>
                   <a:srgbClr val="1B2433"/>
                 </a:solidFill>
                 <a:latin typeface="Calibri"/>
               </a:rPr>
-              <a:t>Same pair twice? </a:t>
-            </a:r>
-            <a:r>
-              <a:rPr sz="1700" b="0" i="0">
+              <a:t>Front + back together </a:t>
+            </a:r>
+            <a:r>
+              <a:rPr sz="1400" b="0" i="0">
                 <a:solidFill>
                   <a:srgbClr val="1B2433"/>
                 </a:solidFill>
                 <a:latin typeface="Calibri"/>
               </a:rPr>
-              <a:t>Cannot be written down.</a:t>
+              <a:t>show every colour twice, so pick one line per cube that touches each dot exactly twice (top left). Same for left + right (bottom left).</a:t>
             </a:r>
           </a:p>
           <a:p>
             <a:pPr algn="l">
               <a:spcAft>
-                <a:spcPts val="1200"/>
+                <a:spcPts val="900"/>
               </a:spcAft>
             </a:pPr>
             <a:r>
-              <a:rPr sz="1700" b="1" i="0">
+              <a:rPr sz="1400" b="1" i="0">
                 <a:solidFill>
                   <a:srgbClr val="1B2433"/>
                 </a:solidFill>
                 <a:latin typeface="Calibri"/>
               </a:rPr>
-              <a:t>One pick per cube? </a:t>
-            </a:r>
-            <a:r>
-              <a:rPr sz="1700" b="0" i="0">
+              <a:t>Which way round </a:t>
+            </a:r>
+            <a:r>
+              <a:rPr sz="1400" b="0" i="0">
                 <a:solidFill>
                   <a:srgbClr val="1B2433"/>
                 </a:solidFill>
                 <a:latin typeface="Calibri"/>
               </a:rPr>
-              <a:t>Automatic.</a:t>
+              <a:t>each pair faces can be fixed afterwards.</a:t>
             </a:r>
           </a:p>
           <a:p>
             <a:pPr algn="l">
               <a:spcAft>
-                <a:spcPts val="1200"/>
+                <a:spcPts val="900"/>
               </a:spcAft>
             </a:pPr>
             <a:r>
-              <a:rPr sz="1700" b="1" i="0">
+              <a:rPr sz="1400" b="0" i="0">
                 <a:solidFill>
                   <a:srgbClr val="1B2433"/>
                 </a:solidFill>
                 <a:latin typeface="Calibri"/>
               </a:rPr>
-              <a:t>Only rule left: </a:t>
-            </a:r>
-            <a:r>
-              <a:rPr sz="1700" b="0" i="0">
+              <a:t>So a cube only picks </a:t>
+            </a:r>
+            <a:r>
+              <a:rPr sz="1400" b="1" i="0">
                 <a:solidFill>
                   <a:srgbClr val="1B2433"/>
                 </a:solidFill>
                 <a:latin typeface="Calibri"/>
               </a:rPr>
-              <a:t>every colour has degree 2 on each side pair.</a:t>
+              <a:t>2 different pairs: 3 × 2 = 6 choices</a:t>
+            </a:r>
+            <a:r>
+              <a:rPr sz="1400" b="0" i="0">
+                <a:solidFill>
+                  <a:srgbClr val="1B2433"/>
+                </a:solidFill>
+                <a:latin typeface="Calibri"/>
+              </a:rPr>
+              <a:t>, stored as a code 0 to 5 in 3 qubits.</a:t>
             </a:r>
           </a:p>
           <a:p>
             <a:pPr algn="l">
               <a:spcAft>
-                <a:spcPts val="1200"/>
+                <a:spcPts val="900"/>
               </a:spcAft>
             </a:pPr>
             <a:r>
-              <a:rPr sz="2000" b="1" i="0">
+              <a:rPr sz="1900" b="1" i="0">
                 <a:solidFill>
                   <a:srgbClr val="0E9488"/>
                 </a:solidFill>
@@ -6682,27 +6821,27 @@
           <a:p>
             <a:pPr algn="l">
               <a:spcAft>
-                <a:spcPts val="1200"/>
+                <a:spcPts val="900"/>
               </a:spcAft>
             </a:pPr>
             <a:r>
-              <a:rPr sz="1700" b="0" i="0">
+              <a:rPr sz="1400" b="0" i="0">
                 <a:solidFill>
                   <a:srgbClr val="1B2433"/>
                 </a:solidFill>
                 <a:latin typeface="Calibri"/>
               </a:rPr>
-              <a:t>Written with Z operators: “cube c holds code k” is a product of (1 ± Z)/2 on its 3 qubits. Terms touch at most 6 qubits (two cubes). 164 terms at N = 4.</a:t>
+              <a:t>d = how many picked lines touch a colour. C = 0 exactly for a solved tower. 164 Z terms at N = 4.</a:t>
             </a:r>
           </a:p>
           <a:p>
             <a:pPr algn="l">
               <a:spcAft>
-                <a:spcPts val="1200"/>
+                <a:spcPts val="900"/>
               </a:spcAft>
             </a:pPr>
             <a:r>
-              <a:rPr sz="1700" b="0" i="1">
+              <a:rPr sz="1400" b="0" i="1">
                 <a:solidFill>
                   <a:srgbClr val="1B2433"/>
                 </a:solidFill>

</xml_diff>

<commit_message>
Layers-to-50% experiment, classical timing, and slide 8 chart
- src/depth_to_50.py: grow each main puzzle's QAOA until P(correct) >= 50%
- src/depth_sweep.py: the same on extra one-tower seeds per size
- src/classical_timing.py: brute force vs graph-method solve times
- Slide 8: layers-to-50% chart, fair comparison with classical, next step

Co-Authored-By: Claude Opus 5.5 <noreply@anthropic.com>
</commit_message>
<xml_diff>
--- a/slides.pptx
+++ b/slides.pptx
@@ -645,6 +645,371 @@
 </c:chartSpace>
 </file>
 
+<file path=ppt/charts/chart3.xml><?xml version="1.0" encoding="utf-8"?>
+<c:chartSpace xmlns:c="http://schemas.openxmlformats.org/drawingml/2006/chart" xmlns:a="http://schemas.openxmlformats.org/drawingml/2006/main" xmlns:r="http://schemas.openxmlformats.org/officeDocument/2006/relationships">
+  <c:chart>
+    <c:autoTitleDeleted val="1"/>
+    <c:plotArea>
+      <c:scatterChart>
+        <c:scatterStyle val="lineMarker"/>
+        <c:varyColors val="0"/>
+        <c:ser>
+          <c:idx val="0"/>
+          <c:order val="0"/>
+          <c:tx>
+            <c:strRef>
+              <c:f>Sheet1!$B$1</c:f>
+              <c:strCache>
+                <c:ptCount val="1"/>
+                <c:pt idx="0">
+                  <c:v>each puzzle</c:v>
+                </c:pt>
+              </c:strCache>
+            </c:strRef>
+          </c:tx>
+          <c:spPr>
+            <a:ln>
+              <a:noFill/>
+            </a:ln>
+          </c:spPr>
+          <c:marker>
+            <c:symbol val="circle"/>
+            <c:size val="8"/>
+            <c:spPr>
+              <a:solidFill>
+                <a:srgbClr val="F0B070"/>
+              </a:solidFill>
+              <a:ln>
+                <a:noFill/>
+              </a:ln>
+            </c:spPr>
+          </c:marker>
+          <c:xVal>
+            <c:numRef>
+              <c:f>Sheet1!$A$2:$A$10</c:f>
+              <c:numCache>
+                <c:formatCode>General</c:formatCode>
+                <c:ptCount val="9"/>
+                <c:pt idx="0">
+                  <c:v>4</c:v>
+                </c:pt>
+                <c:pt idx="1">
+                  <c:v>5</c:v>
+                </c:pt>
+                <c:pt idx="2">
+                  <c:v>5</c:v>
+                </c:pt>
+                <c:pt idx="3">
+                  <c:v>5</c:v>
+                </c:pt>
+                <c:pt idx="4">
+                  <c:v>5</c:v>
+                </c:pt>
+                <c:pt idx="5">
+                  <c:v>5</c:v>
+                </c:pt>
+                <c:pt idx="6">
+                  <c:v>6</c:v>
+                </c:pt>
+                <c:pt idx="7">
+                  <c:v>7</c:v>
+                </c:pt>
+                <c:pt idx="8">
+                  <c:v>8</c:v>
+                </c:pt>
+              </c:numCache>
+            </c:numRef>
+          </c:xVal>
+          <c:yVal>
+            <c:numRef>
+              <c:f>Sheet1!$B$2:$B$10</c:f>
+              <c:numCache>
+                <c:formatCode>General</c:formatCode>
+                <c:ptCount val="9"/>
+                <c:pt idx="0">
+                  <c:v>9</c:v>
+                </c:pt>
+                <c:pt idx="1">
+                  <c:v>24</c:v>
+                </c:pt>
+                <c:pt idx="2">
+                  <c:v>26</c:v>
+                </c:pt>
+                <c:pt idx="3">
+                  <c:v>11</c:v>
+                </c:pt>
+                <c:pt idx="4">
+                  <c:v>19</c:v>
+                </c:pt>
+                <c:pt idx="5">
+                  <c:v>25</c:v>
+                </c:pt>
+                <c:pt idx="6">
+                  <c:v>21</c:v>
+                </c:pt>
+                <c:pt idx="7">
+                  <c:v>33</c:v>
+                </c:pt>
+                <c:pt idx="8">
+                  <c:v>31</c:v>
+                </c:pt>
+              </c:numCache>
+            </c:numRef>
+          </c:yVal>
+          <c:smooth val="0"/>
+        </c:ser>
+        <c:ser>
+          <c:idx val="1"/>
+          <c:order val="1"/>
+          <c:tx>
+            <c:strRef>
+              <c:f>Sheet1!$B$12</c:f>
+              <c:strCache>
+                <c:ptCount val="1"/>
+                <c:pt idx="0">
+                  <c:v>median</c:v>
+                </c:pt>
+              </c:strCache>
+            </c:strRef>
+          </c:tx>
+          <c:spPr>
+            <a:ln w="38100">
+              <a:solidFill>
+                <a:srgbClr val="5FD4C8"/>
+              </a:solidFill>
+            </a:ln>
+          </c:spPr>
+          <c:marker>
+            <c:symbol val="diamond"/>
+            <c:size val="9"/>
+            <c:spPr>
+              <a:solidFill>
+                <a:srgbClr val="5FD4C8"/>
+              </a:solidFill>
+            </c:spPr>
+          </c:marker>
+          <c:xVal>
+            <c:numRef>
+              <c:f>Sheet1!$A$13:$A$17</c:f>
+              <c:numCache>
+                <c:formatCode>General</c:formatCode>
+                <c:ptCount val="5"/>
+                <c:pt idx="0">
+                  <c:v>4</c:v>
+                </c:pt>
+                <c:pt idx="1">
+                  <c:v>5</c:v>
+                </c:pt>
+                <c:pt idx="2">
+                  <c:v>6</c:v>
+                </c:pt>
+                <c:pt idx="3">
+                  <c:v>7</c:v>
+                </c:pt>
+                <c:pt idx="4">
+                  <c:v>8</c:v>
+                </c:pt>
+              </c:numCache>
+            </c:numRef>
+          </c:xVal>
+          <c:yVal>
+            <c:numRef>
+              <c:f>Sheet1!$B$13:$B$17</c:f>
+              <c:numCache>
+                <c:formatCode>General</c:formatCode>
+                <c:ptCount val="5"/>
+                <c:pt idx="0">
+                  <c:v>9</c:v>
+                </c:pt>
+                <c:pt idx="1">
+                  <c:v>24</c:v>
+                </c:pt>
+                <c:pt idx="2">
+                  <c:v>21</c:v>
+                </c:pt>
+                <c:pt idx="3">
+                  <c:v>33</c:v>
+                </c:pt>
+                <c:pt idx="4">
+                  <c:v>31</c:v>
+                </c:pt>
+              </c:numCache>
+            </c:numRef>
+          </c:yVal>
+          <c:smooth val="0"/>
+        </c:ser>
+        <c:axId val="-2128940872"/>
+        <c:axId val="-2129643912"/>
+      </c:scatterChart>
+      <c:valAx>
+        <c:axId val="-2128940872"/>
+        <c:scaling>
+          <c:orientation val="minMax"/>
+          <c:max val="9.0"/>
+          <c:min val="3.0"/>
+        </c:scaling>
+        <c:delete val="0"/>
+        <c:axPos val="b"/>
+        <c:title>
+          <c:tx>
+            <c:rich>
+              <a:bodyPr/>
+              <a:lstStyle/>
+              <a:p>
+                <a:r>
+                  <a:rPr sz="1200" b="0">
+                    <a:solidFill>
+                      <a:srgbClr val="C9D3DA"/>
+                    </a:solidFill>
+                  </a:rPr>
+                  <a:t>N cubes</a:t>
+                </a:r>
+              </a:p>
+            </c:rich>
+          </c:tx>
+          <c:layout/>
+          <c:overlay val="0"/>
+        </c:title>
+        <c:numFmt formatCode="General" sourceLinked="1"/>
+        <c:majorTickMark val="out"/>
+        <c:minorTickMark val="none"/>
+        <c:tickLblPos val="nextTo"/>
+        <c:spPr>
+          <a:ln>
+            <a:solidFill>
+              <a:srgbClr val="4A5A68"/>
+            </a:solidFill>
+          </a:ln>
+        </c:spPr>
+        <c:txPr>
+          <a:bodyPr/>
+          <a:lstStyle/>
+          <a:p>
+            <a:pPr>
+              <a:defRPr>
+                <a:solidFill>
+                  <a:srgbClr val="C9D3DA"/>
+                </a:solidFill>
+              </a:defRPr>
+            </a:pPr>
+          </a:p>
+        </c:txPr>
+        <c:crossAx val="-2129643912"/>
+        <c:crosses val="autoZero"/>
+        <c:crossBetween val="midCat"/>
+        <c:majorUnit val="1.0"/>
+      </c:valAx>
+      <c:valAx>
+        <c:axId val="-2129643912"/>
+        <c:scaling>
+          <c:orientation val="minMax"/>
+          <c:max val="40.0"/>
+          <c:min val="0.0"/>
+        </c:scaling>
+        <c:delete val="0"/>
+        <c:axPos val="l"/>
+        <c:majorGridlines>
+          <c:spPr>
+            <a:ln>
+              <a:solidFill>
+                <a:srgbClr val="2E3D4A"/>
+              </a:solidFill>
+            </a:ln>
+          </c:spPr>
+        </c:majorGridlines>
+        <c:title>
+          <c:tx>
+            <c:rich>
+              <a:bodyPr/>
+              <a:lstStyle/>
+              <a:p>
+                <a:r>
+                  <a:rPr sz="1200" b="0">
+                    <a:solidFill>
+                      <a:srgbClr val="C9D3DA"/>
+                    </a:solidFill>
+                  </a:rPr>
+                  <a:t>layers p</a:t>
+                </a:r>
+              </a:p>
+            </c:rich>
+          </c:tx>
+          <c:layout/>
+          <c:overlay val="0"/>
+        </c:title>
+        <c:numFmt formatCode="General" sourceLinked="1"/>
+        <c:majorTickMark val="out"/>
+        <c:minorTickMark val="none"/>
+        <c:tickLblPos val="nextTo"/>
+        <c:spPr>
+          <a:ln>
+            <a:solidFill>
+              <a:srgbClr val="4A5A68"/>
+            </a:solidFill>
+          </a:ln>
+        </c:spPr>
+        <c:txPr>
+          <a:bodyPr/>
+          <a:lstStyle/>
+          <a:p>
+            <a:pPr>
+              <a:defRPr>
+                <a:solidFill>
+                  <a:srgbClr val="C9D3DA"/>
+                </a:solidFill>
+              </a:defRPr>
+            </a:pPr>
+          </a:p>
+        </c:txPr>
+        <c:crossAx val="-2128940872"/>
+        <c:crosses val="autoZero"/>
+        <c:crossBetween val="midCat"/>
+        <c:majorUnit val="10.0"/>
+      </c:valAx>
+    </c:plotArea>
+    <c:legend>
+      <c:legendPos val="b"/>
+      <c:layout/>
+      <c:overlay val="0"/>
+      <c:txPr>
+        <a:bodyPr/>
+        <a:lstStyle/>
+        <a:p>
+          <a:pPr>
+            <a:defRPr>
+              <a:solidFill>
+                <a:srgbClr val="C9D3DA"/>
+              </a:solidFill>
+            </a:defRPr>
+          </a:pPr>
+        </a:p>
+      </c:txPr>
+    </c:legend>
+    <c:plotVisOnly val="1"/>
+    <c:dispBlanksAs val="gap"/>
+    <c:showDLblsOverMax val="0"/>
+  </c:chart>
+  <c:txPr>
+    <a:bodyPr/>
+    <a:lstStyle/>
+    <a:p>
+      <a:pPr>
+        <a:defRPr sz="1200">
+          <a:solidFill>
+            <a:srgbClr val="C9D3DA"/>
+          </a:solidFill>
+          <a:latin typeface="Calibri"/>
+        </a:defRPr>
+      </a:pPr>
+      <a:endParaRPr lang="en-US"/>
+    </a:p>
+  </c:txPr>
+  <c:externalData r:id="rId1">
+    <c:autoUpdate val="0"/>
+  </c:externalData>
+</c:chartSpace>
+</file>
+
 <file path=ppt/notesMasters/notesMaster1.xml><?xml version="1.0" encoding="utf-8"?>
 <p:notesMaster xmlns:a="http://schemas.openxmlformats.org/drawingml/2006/main" xmlns:p="http://schemas.openxmlformats.org/presentationml/2006/main" xmlns:r="http://schemas.openxmlformats.org/officeDocument/2006/relationships">
   <p:cSld>
@@ -1530,7 +1895,7 @@
           <a:lstStyle/>
           <a:p>
             <a:r>
-              <a:t>Speaker 3: close with honesty — what works, what doesn't scale, and the one next experiment.</a:t>
+              <a:t>Speaker 3: the chart answers 'how many layers to keep success at 50%?'. Then the fair comparison: classical wins clearly at these sizes. Close with the next step.</a:t>
             </a:r>
           </a:p>
         </p:txBody>
@@ -11039,8 +11404,8 @@
         </p:nvSpPr>
         <p:spPr>
           <a:xfrm>
-            <a:off x="822960" y="640080"/>
-            <a:ext cx="182880" cy="182880"/>
+            <a:off x="822960" y="502920"/>
+            <a:ext cx="155448" cy="155448"/>
           </a:xfrm>
           <a:prstGeom prst="roundRect">
             <a:avLst/>
@@ -11082,8 +11447,8 @@
         </p:nvSpPr>
         <p:spPr>
           <a:xfrm>
-            <a:off x="822960" y="859536"/>
-            <a:ext cx="182880" cy="182880"/>
+            <a:off x="822960" y="694944"/>
+            <a:ext cx="155448" cy="155448"/>
           </a:xfrm>
           <a:prstGeom prst="roundRect">
             <a:avLst/>
@@ -11125,8 +11490,8 @@
         </p:nvSpPr>
         <p:spPr>
           <a:xfrm>
-            <a:off x="822960" y="1078992"/>
-            <a:ext cx="182880" cy="182880"/>
+            <a:off x="822960" y="886968"/>
+            <a:ext cx="155448" cy="155448"/>
           </a:xfrm>
           <a:prstGeom prst="roundRect">
             <a:avLst/>
@@ -11168,8 +11533,8 @@
         </p:nvSpPr>
         <p:spPr>
           <a:xfrm>
-            <a:off x="822960" y="1298448"/>
-            <a:ext cx="182880" cy="182880"/>
+            <a:off x="822960" y="1078992"/>
+            <a:ext cx="155448" cy="155448"/>
           </a:xfrm>
           <a:prstGeom prst="roundRect">
             <a:avLst/>
@@ -11211,8 +11576,8 @@
         </p:nvSpPr>
         <p:spPr>
           <a:xfrm>
-            <a:off x="1280160" y="502920"/>
-            <a:ext cx="10058400" cy="822960"/>
+            <a:off x="1234440" y="365760"/>
+            <a:ext cx="10515600" cy="731520"/>
           </a:xfrm>
           <a:prstGeom prst="rect">
             <a:avLst/>
@@ -11231,7 +11596,7 @@
               </a:spcAft>
             </a:pPr>
             <a:r>
-              <a:rPr sz="3400" b="1" i="0">
+              <a:rPr sz="3200" b="1" i="0">
                 <a:solidFill>
                   <a:srgbClr val="FFFFFF"/>
                 </a:solidFill>
@@ -11250,8 +11615,8 @@
         </p:nvSpPr>
         <p:spPr>
           <a:xfrm>
-            <a:off x="822960" y="1645920"/>
-            <a:ext cx="5120640" cy="4572000"/>
+            <a:off x="731520" y="1325880"/>
+            <a:ext cx="5852160" cy="457200"/>
           </a:xfrm>
           <a:prstGeom prst="rect">
             <a:avLst/>
@@ -11266,11 +11631,107 @@
           <a:p>
             <a:pPr algn="l">
               <a:spcAft>
-                <a:spcPts val="1200"/>
+                <a:spcPts val="600"/>
               </a:spcAft>
             </a:pPr>
             <a:r>
-              <a:rPr sz="2200" b="1" i="0">
+              <a:rPr sz="1600" b="1" i="0">
+                <a:solidFill>
+                  <a:srgbClr val="FFFFFF"/>
+                </a:solidFill>
+                <a:latin typeface="Calibri"/>
+              </a:rPr>
+              <a:t>Layers needed to reach 50% success</a:t>
+            </a:r>
+          </a:p>
+        </p:txBody>
+      </p:sp>
+      <p:graphicFrame>
+        <p:nvGraphicFramePr>
+          <p:cNvPr id="8" name="Chart 7"/>
+          <p:cNvGraphicFramePr>
+            <a:graphicFrameLocks noGrp="1"/>
+          </p:cNvGraphicFramePr>
+          <p:nvPr/>
+        </p:nvGraphicFramePr>
+        <p:xfrm>
+          <a:off x="548640" y="1691640"/>
+          <a:ext cx="6035040" cy="4023360"/>
+        </p:xfrm>
+        <a:graphic>
+          <a:graphicData uri="http://schemas.openxmlformats.org/drawingml/2006/chart">
+            <c:chart xmlns:c="http://schemas.openxmlformats.org/drawingml/2006/chart" r:id="rId2"/>
+          </a:graphicData>
+        </a:graphic>
+      </p:graphicFrame>
+      <p:sp>
+        <p:nvSpPr>
+          <p:cNvPr id="9" name="TextBox 8"/>
+          <p:cNvSpPr txBox="1"/>
+          <p:nvPr/>
+        </p:nvSpPr>
+        <p:spPr>
+          <a:xfrm>
+            <a:off x="731520" y="5806440"/>
+            <a:ext cx="5852160" cy="822960"/>
+          </a:xfrm>
+          <a:prstGeom prst="rect">
+            <a:avLst/>
+          </a:prstGeom>
+          <a:noFill/>
+        </p:spPr>
+        <p:txBody>
+          <a:bodyPr wrap="square" anchor="t" lIns="0" rIns="0">
+            <a:spAutoFit/>
+          </a:bodyPr>
+          <a:lstStyle/>
+          <a:p>
+            <a:pPr algn="l">
+              <a:spcAft>
+                <a:spcPts val="600"/>
+              </a:spcAft>
+            </a:pPr>
+            <a:r>
+              <a:rPr sz="1200" b="0" i="0">
+                <a:solidFill>
+                  <a:srgbClr val="C9D3DA"/>
+                </a:solidFill>
+                <a:latin typeface="Calibri"/>
+              </a:rPr>
+              <a:t>9 puzzles, exact simulation, angles tuned on the average cost only. Puzzles of the same size differ a lot, so one puzzle per size is not enough.</a:t>
+            </a:r>
+          </a:p>
+        </p:txBody>
+      </p:sp>
+      <p:sp>
+        <p:nvSpPr>
+          <p:cNvPr id="10" name="TextBox 9"/>
+          <p:cNvSpPr txBox="1"/>
+          <p:nvPr/>
+        </p:nvSpPr>
+        <p:spPr>
+          <a:xfrm>
+            <a:off x="6949440" y="1325880"/>
+            <a:ext cx="4754880" cy="5303520"/>
+          </a:xfrm>
+          <a:prstGeom prst="rect">
+            <a:avLst/>
+          </a:prstGeom>
+          <a:noFill/>
+        </p:spPr>
+        <p:txBody>
+          <a:bodyPr wrap="square" anchor="t" lIns="0" rIns="0">
+            <a:spAutoFit/>
+          </a:bodyPr>
+          <a:lstStyle/>
+          <a:p>
+            <a:pPr algn="l">
+              <a:spcAft>
+                <a:spcPts val="700"/>
+              </a:spcAft>
+            </a:pPr>
+            <a:r>
+              <a:rPr sz="1900" b="1" i="0">
                 <a:solidFill>
                   <a:srgbClr val="5FD4C8"/>
                 </a:solidFill>
@@ -11282,155 +11743,141 @@
           <a:p>
             <a:pPr algn="l">
               <a:spcAft>
-                <a:spcPts val="1200"/>
+                <a:spcPts val="700"/>
               </a:spcAft>
             </a:pPr>
             <a:r>
-              <a:rPr sz="1600" b="0" i="0">
+              <a:rPr sz="1400" b="0" i="0">
                 <a:solidFill>
                   <a:srgbClr val="C9D3DA"/>
                 </a:solidFill>
                 <a:latin typeface="Calibri"/>
               </a:rPr>
-              <a:t>Building the rules into the encoding (3 qubits per cube) beat penalty terms: fewer qubits, nothing to tune, no wasted shots.</a:t>
+              <a:t>Rules built into the encoding: half the qubits, no penalties, 0 wasted shots.</a:t>
             </a:r>
           </a:p>
           <a:p>
             <a:pPr algn="l">
               <a:spcAft>
-                <a:spcPts val="1200"/>
+                <a:spcPts val="700"/>
               </a:spcAft>
             </a:pPr>
             <a:r>
-              <a:rPr sz="1600" b="0" i="0">
+              <a:rPr sz="1400" b="0" i="0">
                 <a:solidFill>
                   <a:srgbClr val="C9D3DA"/>
                 </a:solidFill>
                 <a:latin typeface="Calibri"/>
               </a:rPr>
-              <a:t>QAOA really concentrates probability on the answer, and checks show it is the right answer.</a:t>
+              <a:t>QAOA concentrates probability on the answer (73% vs 0.15% guessing), checked shot by shot.</a:t>
             </a:r>
           </a:p>
           <a:p>
             <a:pPr algn="l">
               <a:spcAft>
-                <a:spcPts val="1200"/>
+                <a:spcPts val="700"/>
               </a:spcAft>
             </a:pPr>
             <a:r>
-              <a:rPr sz="1600" b="0" i="0">
+              <a:rPr sz="1400" b="0" i="0">
                 <a:solidFill>
                   <a:srgbClr val="C9D3DA"/>
                 </a:solidFill>
                 <a:latin typeface="Calibri"/>
               </a:rPr>
-              <a:t>No speedup: brute force takes 0.14 s, and tuning needed a full classical simulation.</a:t>
+              <a:t>Layers needed grow with N, and vary a lot between puzzles of the same size.</a:t>
             </a:r>
           </a:p>
           <a:p>
             <a:pPr algn="l">
               <a:spcAft>
-                <a:spcPts val="1200"/>
+                <a:spcPts val="700"/>
               </a:spcAft>
             </a:pPr>
             <a:r>
-              <a:rPr sz="1600" b="0" i="0">
+              <a:rPr sz="1900" b="1" i="0">
+                <a:solidFill>
+                  <a:srgbClr val="F0B070"/>
+                </a:solidFill>
+                <a:latin typeface="Cambria"/>
+              </a:rPr>
+              <a:t>Fair comparison: no quantum advantage</a:t>
+            </a:r>
+          </a:p>
+          <a:p>
+            <a:pPr algn="l">
+              <a:spcAft>
+                <a:spcPts val="700"/>
+              </a:spcAft>
+            </a:pPr>
+            <a:r>
+              <a:rPr sz="1400" b="0" i="0">
                 <a:solidFill>
                   <a:srgbClr val="C9D3DA"/>
                 </a:solidFill>
                 <a:latin typeface="Calibri"/>
               </a:rPr>
-              <a:t>Success at fixed depth falls with N; gates grow with N.</a:t>
-            </a:r>
-          </a:p>
-        </p:txBody>
-      </p:sp>
-      <p:sp>
-        <p:nvSpPr>
-          <p:cNvPr id="8" name="TextBox 7"/>
-          <p:cNvSpPr txBox="1"/>
-          <p:nvPr/>
-        </p:nvSpPr>
-        <p:spPr>
-          <a:xfrm>
-            <a:off x="6400800" y="1645920"/>
-            <a:ext cx="5120640" cy="4572000"/>
-          </a:xfrm>
-          <a:prstGeom prst="rect">
-            <a:avLst/>
-          </a:prstGeom>
-          <a:noFill/>
-        </p:spPr>
-        <p:txBody>
-          <a:bodyPr wrap="square" anchor="t" lIns="0" rIns="0">
-            <a:spAutoFit/>
-          </a:bodyPr>
-          <a:lstStyle/>
-          <a:p>
-            <a:pPr algn="l">
-              <a:spcAft>
-                <a:spcPts val="1200"/>
-              </a:spcAft>
-            </a:pPr>
-            <a:r>
-              <a:rPr sz="2200" b="1" i="0">
-                <a:solidFill>
-                  <a:srgbClr val="F0B070"/>
-                </a:solidFill>
-                <a:latin typeface="Cambria"/>
-              </a:rPr>
-              <a:t>Next step</a:t>
-            </a:r>
-          </a:p>
-          <a:p>
-            <a:pPr algn="l">
-              <a:spcAft>
-                <a:spcPts val="1200"/>
-              </a:spcAft>
-            </a:pPr>
-            <a:r>
-              <a:rPr sz="1600" b="1" i="0">
-                <a:solidFill>
-                  <a:srgbClr val="FFFFFF"/>
-                </a:solidFill>
-                <a:latin typeface="Calibri"/>
-              </a:rPr>
-              <a:t>Measure how many layers keep success at 50% as N grows, </a:t>
-            </a:r>
-            <a:r>
-              <a:rPr sz="1600" b="0" i="0">
+              <a:t>A smart classical solver finds the 8-cube tower in 13 ms. </a:t>
+            </a:r>
+            <a:r>
+              <a:rPr sz="1400" b="0" i="0">
                 <a:solidFill>
                   <a:srgbClr val="C9D3DA"/>
                 </a:solidFill>
                 <a:latin typeface="Calibri"/>
               </a:rPr>
-              <a:t>using a CVaR objective and angles transferred from smaller N.</a:t>
-            </a:r>
-          </a:p>
-          <a:p>
-            <a:pPr algn="l">
-              <a:spcAft>
-                <a:spcPts val="1200"/>
-              </a:spcAft>
-            </a:pPr>
-            <a:r>
-              <a:rPr sz="1600" b="0" i="0">
+              <a:t>QAOA would need about 65,000 CNOTs per shot at 50%, </a:t>
+            </a:r>
+            <a:r>
+              <a:rPr sz="1400" b="0" i="0">
                 <a:solidFill>
                   <a:srgbClr val="C9D3DA"/>
                 </a:solidFill>
                 <a:latin typeface="Calibri"/>
               </a:rPr>
-              <a:t>Also: reorder cost terms to cancel CNOTs; a Grover search with a reversible degree-counting oracle; one shallow run on real hardware next to SV1.</a:t>
+              <a:t>plus thousands of runs to tune: far beyond today's hardware.</a:t>
             </a:r>
           </a:p>
           <a:p>
             <a:pPr algn="l">
               <a:spcAft>
-                <a:spcPts val="1200"/>
+                <a:spcPts val="700"/>
               </a:spcAft>
             </a:pPr>
             <a:r>
-              <a:rPr sz="1600" b="0" i="1">
+              <a:rPr sz="1900" b="1" i="0">
+                <a:solidFill>
+                  <a:srgbClr val="FFFFFF"/>
+                </a:solidFill>
+                <a:latin typeface="Cambria"/>
+              </a:rPr>
+              <a:t>Next step</a:t>
+            </a:r>
+          </a:p>
+          <a:p>
+            <a:pPr algn="l">
+              <a:spcAft>
+                <a:spcPts val="700"/>
+              </a:spcAft>
+            </a:pPr>
+            <a:r>
+              <a:rPr sz="1400" b="0" i="0">
+                <a:solidFill>
+                  <a:srgbClr val="C9D3DA"/>
+                </a:solidFill>
+                <a:latin typeface="Calibri"/>
+              </a:rPr>
+              <a:t>Track how layers grow at larger N, with CVaR (tune for the best shots, not the average).</a:t>
+            </a:r>
+          </a:p>
+          <a:p>
+            <a:pPr algn="l">
+              <a:spcAft>
+                <a:spcPts val="700"/>
+              </a:spcAft>
+            </a:pPr>
+            <a:r>
+              <a:rPr sz="1200" b="0" i="1">
                 <a:solidFill>
                   <a:srgbClr val="C9D3DA"/>
                 </a:solidFill>

</xml_diff>

<commit_message>
Slide 8: match the deck's light theme; include finished extra puzzles
Co-Authored-By: Claude Opus 5.5 <noreply@anthropic.com>
</commit_message>
<xml_diff>
--- a/slides.pptx
+++ b/slides.pptx
@@ -677,7 +677,7 @@
             <c:size val="8"/>
             <c:spPr>
               <a:solidFill>
-                <a:srgbClr val="F0B070"/>
+                <a:srgbClr val="C2772A"/>
               </a:solidFill>
               <a:ln>
                 <a:noFill/>
@@ -686,10 +686,10 @@
           </c:marker>
           <c:xVal>
             <c:numRef>
-              <c:f>Sheet1!$A$2:$A$10</c:f>
+              <c:f>Sheet1!$A$2:$A$14</c:f>
               <c:numCache>
                 <c:formatCode>General</c:formatCode>
-                <c:ptCount val="9"/>
+                <c:ptCount val="13"/>
                 <c:pt idx="0">
                   <c:v>4</c:v>
                 </c:pt>
@@ -712,9 +712,21 @@
                   <c:v>6</c:v>
                 </c:pt>
                 <c:pt idx="7">
+                  <c:v>6</c:v>
+                </c:pt>
+                <c:pt idx="8">
+                  <c:v>6</c:v>
+                </c:pt>
+                <c:pt idx="9">
+                  <c:v>6</c:v>
+                </c:pt>
+                <c:pt idx="10">
+                  <c:v>6</c:v>
+                </c:pt>
+                <c:pt idx="11">
                   <c:v>7</c:v>
                 </c:pt>
-                <c:pt idx="8">
+                <c:pt idx="12">
                   <c:v>8</c:v>
                 </c:pt>
               </c:numCache>
@@ -722,10 +734,10 @@
           </c:xVal>
           <c:yVal>
             <c:numRef>
-              <c:f>Sheet1!$B$2:$B$10</c:f>
+              <c:f>Sheet1!$B$2:$B$14</c:f>
               <c:numCache>
                 <c:formatCode>General</c:formatCode>
-                <c:ptCount val="9"/>
+                <c:ptCount val="13"/>
                 <c:pt idx="0">
                   <c:v>9</c:v>
                 </c:pt>
@@ -748,9 +760,21 @@
                   <c:v>21</c:v>
                 </c:pt>
                 <c:pt idx="7">
+                  <c:v>34</c:v>
+                </c:pt>
+                <c:pt idx="8">
+                  <c:v>24</c:v>
+                </c:pt>
+                <c:pt idx="9">
+                  <c:v>25</c:v>
+                </c:pt>
+                <c:pt idx="10">
+                  <c:v>24</c:v>
+                </c:pt>
+                <c:pt idx="11">
                   <c:v>33</c:v>
                 </c:pt>
-                <c:pt idx="8">
+                <c:pt idx="12">
                   <c:v>31</c:v>
                 </c:pt>
               </c:numCache>
@@ -763,7 +787,7 @@
           <c:order val="1"/>
           <c:tx>
             <c:strRef>
-              <c:f>Sheet1!$B$12</c:f>
+              <c:f>Sheet1!$B$16</c:f>
               <c:strCache>
                 <c:ptCount val="1"/>
                 <c:pt idx="0">
@@ -773,9 +797,9 @@
             </c:strRef>
           </c:tx>
           <c:spPr>
-            <a:ln w="38100">
+            <a:ln w="31750">
               <a:solidFill>
-                <a:srgbClr val="5FD4C8"/>
+                <a:srgbClr val="0E9488"/>
               </a:solidFill>
             </a:ln>
           </c:spPr>
@@ -784,13 +808,13 @@
             <c:size val="9"/>
             <c:spPr>
               <a:solidFill>
-                <a:srgbClr val="5FD4C8"/>
+                <a:srgbClr val="0E9488"/>
               </a:solidFill>
             </c:spPr>
           </c:marker>
           <c:xVal>
             <c:numRef>
-              <c:f>Sheet1!$A$13:$A$17</c:f>
+              <c:f>Sheet1!$A$17:$A$21</c:f>
               <c:numCache>
                 <c:formatCode>General</c:formatCode>
                 <c:ptCount val="5"/>
@@ -814,7 +838,7 @@
           </c:xVal>
           <c:yVal>
             <c:numRef>
-              <c:f>Sheet1!$B$13:$B$17</c:f>
+              <c:f>Sheet1!$B$17:$B$21</c:f>
               <c:numCache>
                 <c:formatCode>General</c:formatCode>
                 <c:ptCount val="5"/>
@@ -825,7 +849,7 @@
                   <c:v>24</c:v>
                 </c:pt>
                 <c:pt idx="2">
-                  <c:v>21</c:v>
+                  <c:v>24</c:v>
                 </c:pt>
                 <c:pt idx="3">
                   <c:v>33</c:v>
@@ -859,7 +883,7 @@
                 <a:r>
                   <a:rPr sz="1200" b="0">
                     <a:solidFill>
-                      <a:srgbClr val="C9D3DA"/>
+                      <a:srgbClr val="5B6575"/>
                     </a:solidFill>
                   </a:rPr>
                   <a:t>N cubes</a:t>
@@ -874,26 +898,6 @@
         <c:majorTickMark val="out"/>
         <c:minorTickMark val="none"/>
         <c:tickLblPos val="nextTo"/>
-        <c:spPr>
-          <a:ln>
-            <a:solidFill>
-              <a:srgbClr val="4A5A68"/>
-            </a:solidFill>
-          </a:ln>
-        </c:spPr>
-        <c:txPr>
-          <a:bodyPr/>
-          <a:lstStyle/>
-          <a:p>
-            <a:pPr>
-              <a:defRPr>
-                <a:solidFill>
-                  <a:srgbClr val="C9D3DA"/>
-                </a:solidFill>
-              </a:defRPr>
-            </a:pPr>
-          </a:p>
-        </c:txPr>
         <c:crossAx val="-2129643912"/>
         <c:crosses val="autoZero"/>
         <c:crossBetween val="midCat"/>
@@ -912,7 +916,7 @@
           <c:spPr>
             <a:ln>
               <a:solidFill>
-                <a:srgbClr val="2E3D4A"/>
+                <a:srgbClr val="DDDDDD"/>
               </a:solidFill>
             </a:ln>
           </c:spPr>
@@ -926,7 +930,7 @@
                 <a:r>
                   <a:rPr sz="1200" b="0">
                     <a:solidFill>
-                      <a:srgbClr val="C9D3DA"/>
+                      <a:srgbClr val="5B6575"/>
                     </a:solidFill>
                   </a:rPr>
                   <a:t>layers p</a:t>
@@ -943,24 +947,9 @@
         <c:tickLblPos val="nextTo"/>
         <c:spPr>
           <a:ln>
-            <a:solidFill>
-              <a:srgbClr val="4A5A68"/>
-            </a:solidFill>
+            <a:noFill/>
           </a:ln>
         </c:spPr>
-        <c:txPr>
-          <a:bodyPr/>
-          <a:lstStyle/>
-          <a:p>
-            <a:pPr>
-              <a:defRPr>
-                <a:solidFill>
-                  <a:srgbClr val="C9D3DA"/>
-                </a:solidFill>
-              </a:defRPr>
-            </a:pPr>
-          </a:p>
-        </c:txPr>
         <c:crossAx val="-2128940872"/>
         <c:crosses val="autoZero"/>
         <c:crossBetween val="midCat"/>
@@ -971,19 +960,6 @@
       <c:legendPos val="b"/>
       <c:layout/>
       <c:overlay val="0"/>
-      <c:txPr>
-        <a:bodyPr/>
-        <a:lstStyle/>
-        <a:p>
-          <a:pPr>
-            <a:defRPr>
-              <a:solidFill>
-                <a:srgbClr val="C9D3DA"/>
-              </a:solidFill>
-            </a:defRPr>
-          </a:pPr>
-        </a:p>
-      </c:txPr>
     </c:legend>
     <c:plotVisOnly val="1"/>
     <c:dispBlanksAs val="gap"/>
@@ -996,7 +972,7 @@
       <a:pPr>
         <a:defRPr sz="1200">
           <a:solidFill>
-            <a:srgbClr val="C9D3DA"/>
+            <a:srgbClr val="5B6575"/>
           </a:solidFill>
           <a:latin typeface="Calibri"/>
         </a:defRPr>
@@ -11381,14 +11357,6 @@
 <file path=ppt/slides/slide8.xml><?xml version="1.0" encoding="utf-8"?>
 <p:sld xmlns:a="http://schemas.openxmlformats.org/drawingml/2006/main" xmlns:p="http://schemas.openxmlformats.org/presentationml/2006/main" xmlns:r="http://schemas.openxmlformats.org/officeDocument/2006/relationships">
   <p:cSld>
-    <p:bg>
-      <p:bgPr>
-        <a:solidFill>
-          <a:srgbClr val="13202B"/>
-        </a:solidFill>
-        <a:effectLst/>
-      </p:bgPr>
-    </p:bg>
     <p:spTree>
       <p:nvGrpSpPr>
         <p:cNvPr id="1" name=""/>
@@ -11404,7 +11372,7 @@
         </p:nvSpPr>
         <p:spPr>
           <a:xfrm>
-            <a:off x="822960" y="502920"/>
+            <a:off x="548640" y="411480"/>
             <a:ext cx="155448" cy="155448"/>
           </a:xfrm>
           <a:prstGeom prst="roundRect">
@@ -11447,7 +11415,7 @@
         </p:nvSpPr>
         <p:spPr>
           <a:xfrm>
-            <a:off x="822960" y="694944"/>
+            <a:off x="548640" y="603504"/>
             <a:ext cx="155448" cy="155448"/>
           </a:xfrm>
           <a:prstGeom prst="roundRect">
@@ -11490,7 +11458,7 @@
         </p:nvSpPr>
         <p:spPr>
           <a:xfrm>
-            <a:off x="822960" y="886968"/>
+            <a:off x="548640" y="795528"/>
             <a:ext cx="155448" cy="155448"/>
           </a:xfrm>
           <a:prstGeom prst="roundRect">
@@ -11533,7 +11501,7 @@
         </p:nvSpPr>
         <p:spPr>
           <a:xfrm>
-            <a:off x="822960" y="1078992"/>
+            <a:off x="548640" y="987552"/>
             <a:ext cx="155448" cy="155448"/>
           </a:xfrm>
           <a:prstGeom prst="roundRect">
@@ -11576,7 +11544,7 @@
         </p:nvSpPr>
         <p:spPr>
           <a:xfrm>
-            <a:off x="1234440" y="365760"/>
+            <a:off x="960120" y="347472"/>
             <a:ext cx="10515600" cy="731520"/>
           </a:xfrm>
           <a:prstGeom prst="rect">
@@ -11596,9 +11564,9 @@
               </a:spcAft>
             </a:pPr>
             <a:r>
-              <a:rPr sz="3200" b="1" i="0">
+              <a:rPr sz="3400" b="1" i="0">
                 <a:solidFill>
-                  <a:srgbClr val="FFFFFF"/>
+                  <a:srgbClr val="1B2433"/>
                 </a:solidFill>
                 <a:latin typeface="Cambria"/>
               </a:rPr>
@@ -11615,8 +11583,8 @@
         </p:nvSpPr>
         <p:spPr>
           <a:xfrm>
-            <a:off x="731520" y="1325880"/>
-            <a:ext cx="5852160" cy="457200"/>
+            <a:off x="960120" y="1051560"/>
+            <a:ext cx="10515600" cy="457200"/>
           </a:xfrm>
           <a:prstGeom prst="rect">
             <a:avLst/>
@@ -11635,9 +11603,48 @@
               </a:spcAft>
             </a:pPr>
             <a:r>
-              <a:rPr sz="1600" b="1" i="0">
+              <a:rPr sz="1600" b="0" i="0">
                 <a:solidFill>
-                  <a:srgbClr val="FFFFFF"/>
+                  <a:srgbClr val="5B6575"/>
+                </a:solidFill>
+                <a:latin typeface="Calibri"/>
+              </a:rPr>
+              <a:t>How many layers QAOA needs, and how it compares with a real classical solver</a:t>
+            </a:r>
+          </a:p>
+        </p:txBody>
+      </p:sp>
+      <p:sp>
+        <p:nvSpPr>
+          <p:cNvPr id="8" name="TextBox 7"/>
+          <p:cNvSpPr txBox="1"/>
+          <p:nvPr/>
+        </p:nvSpPr>
+        <p:spPr>
+          <a:xfrm>
+            <a:off x="731520" y="1600200"/>
+            <a:ext cx="5852160" cy="365760"/>
+          </a:xfrm>
+          <a:prstGeom prst="rect">
+            <a:avLst/>
+          </a:prstGeom>
+          <a:noFill/>
+        </p:spPr>
+        <p:txBody>
+          <a:bodyPr wrap="square" anchor="t" lIns="0" rIns="0">
+            <a:spAutoFit/>
+          </a:bodyPr>
+          <a:lstStyle/>
+          <a:p>
+            <a:pPr algn="l">
+              <a:spcAft>
+                <a:spcPts val="600"/>
+              </a:spcAft>
+            </a:pPr>
+            <a:r>
+              <a:rPr sz="1500" b="1" i="0">
+                <a:solidFill>
+                  <a:srgbClr val="1B2433"/>
                 </a:solidFill>
                 <a:latin typeface="Calibri"/>
               </a:rPr>
@@ -11648,15 +11655,15 @@
       </p:sp>
       <p:graphicFrame>
         <p:nvGraphicFramePr>
-          <p:cNvPr id="8" name="Chart 7"/>
+          <p:cNvPr id="9" name="Chart 8"/>
           <p:cNvGraphicFramePr>
             <a:graphicFrameLocks noGrp="1"/>
           </p:cNvGraphicFramePr>
           <p:nvPr/>
         </p:nvGraphicFramePr>
         <p:xfrm>
-          <a:off x="548640" y="1691640"/>
-          <a:ext cx="6035040" cy="4023360"/>
+          <a:off x="548640" y="1920240"/>
+          <a:ext cx="6035040" cy="3931920"/>
         </p:xfrm>
         <a:graphic>
           <a:graphicData uri="http://schemas.openxmlformats.org/drawingml/2006/chart">
@@ -11666,14 +11673,14 @@
       </p:graphicFrame>
       <p:sp>
         <p:nvSpPr>
-          <p:cNvPr id="9" name="TextBox 8"/>
+          <p:cNvPr id="10" name="TextBox 9"/>
           <p:cNvSpPr txBox="1"/>
           <p:nvPr/>
         </p:nvSpPr>
         <p:spPr>
           <a:xfrm>
-            <a:off x="731520" y="5806440"/>
-            <a:ext cx="5852160" cy="822960"/>
+            <a:off x="731520" y="5943600"/>
+            <a:ext cx="5852160" cy="731520"/>
           </a:xfrm>
           <a:prstGeom prst="rect">
             <a:avLst/>
@@ -11694,25 +11701,70 @@
             <a:r>
               <a:rPr sz="1200" b="0" i="0">
                 <a:solidFill>
-                  <a:srgbClr val="C9D3DA"/>
+                  <a:srgbClr val="5B6575"/>
                 </a:solidFill>
                 <a:latin typeface="Calibri"/>
               </a:rPr>
-              <a:t>9 puzzles, exact simulation, angles tuned on the average cost only. Puzzles of the same size differ a lot, so one puzzle per size is not enough.</a:t>
-            </a:r>
-          </a:p>
-        </p:txBody>
-      </p:sp>
-      <p:sp>
-        <p:nvSpPr>
-          <p:cNvPr id="10" name="TextBox 9"/>
+              <a:t>13 puzzles, exact simulation, angles tuned on the average cost only. Puzzles of the same size differ a lot, so one puzzle per size is not enough.</a:t>
+            </a:r>
+          </a:p>
+        </p:txBody>
+      </p:sp>
+      <p:sp>
+        <p:nvSpPr>
+          <p:cNvPr id="11" name="Rounded Rectangle 10"/>
+          <p:cNvSpPr/>
+          <p:nvPr/>
+        </p:nvSpPr>
+        <p:spPr>
+          <a:xfrm>
+            <a:off x="6949440" y="1600200"/>
+            <a:ext cx="4754880" cy="1965960"/>
+          </a:xfrm>
+          <a:prstGeom prst="roundRect">
+            <a:avLst>
+              <a:gd name="adj" fmla="val 6000"/>
+            </a:avLst>
+          </a:prstGeom>
+          <a:solidFill>
+            <a:srgbClr val="E8F4F3"/>
+          </a:solidFill>
+          <a:ln>
+            <a:noFill/>
+          </a:ln>
+        </p:spPr>
+        <p:style>
+          <a:lnRef idx="1">
+            <a:schemeClr val="accent1"/>
+          </a:lnRef>
+          <a:fillRef idx="3">
+            <a:schemeClr val="accent1"/>
+          </a:fillRef>
+          <a:effectRef idx="2">
+            <a:schemeClr val="accent1"/>
+          </a:effectRef>
+          <a:fontRef idx="minor">
+            <a:schemeClr val="lt1"/>
+          </a:fontRef>
+        </p:style>
+        <p:txBody>
+          <a:bodyPr rtlCol="0" anchor="ctr"/>
+          <a:lstStyle/>
+          <a:p>
+            <a:pPr algn="ctr"/>
+          </a:p>
+        </p:txBody>
+      </p:sp>
+      <p:sp>
+        <p:nvSpPr>
+          <p:cNvPr id="12" name="TextBox 11"/>
           <p:cNvSpPr txBox="1"/>
           <p:nvPr/>
         </p:nvSpPr>
         <p:spPr>
           <a:xfrm>
-            <a:off x="6949440" y="1325880"/>
-            <a:ext cx="4754880" cy="5303520"/>
+            <a:off x="7178040" y="1691640"/>
+            <a:ext cx="4389120" cy="1828800"/>
           </a:xfrm>
           <a:prstGeom prst="rect">
             <a:avLst/>
@@ -11727,13 +11779,13 @@
           <a:p>
             <a:pPr algn="l">
               <a:spcAft>
-                <a:spcPts val="700"/>
+                <a:spcPts val="400"/>
               </a:spcAft>
             </a:pPr>
             <a:r>
-              <a:rPr sz="1900" b="1" i="0">
+              <a:rPr sz="1700" b="1" i="0">
                 <a:solidFill>
-                  <a:srgbClr val="5FD4C8"/>
+                  <a:srgbClr val="0E9488"/>
                 </a:solidFill>
                 <a:latin typeface="Cambria"/>
               </a:rPr>
@@ -11743,13 +11795,13 @@
           <a:p>
             <a:pPr algn="l">
               <a:spcAft>
-                <a:spcPts val="700"/>
+                <a:spcPts val="400"/>
               </a:spcAft>
             </a:pPr>
             <a:r>
-              <a:rPr sz="1400" b="0" i="0">
+              <a:rPr sz="1300" b="0" i="0">
                 <a:solidFill>
-                  <a:srgbClr val="C9D3DA"/>
+                  <a:srgbClr val="1B2433"/>
                 </a:solidFill>
                 <a:latin typeface="Calibri"/>
               </a:rPr>
@@ -11759,13 +11811,13 @@
           <a:p>
             <a:pPr algn="l">
               <a:spcAft>
-                <a:spcPts val="700"/>
+                <a:spcPts val="400"/>
               </a:spcAft>
             </a:pPr>
             <a:r>
-              <a:rPr sz="1400" b="0" i="0">
+              <a:rPr sz="1300" b="0" i="0">
                 <a:solidFill>
-                  <a:srgbClr val="C9D3DA"/>
+                  <a:srgbClr val="1B2433"/>
                 </a:solidFill>
                 <a:latin typeface="Calibri"/>
               </a:rPr>
@@ -11775,29 +11827,97 @@
           <a:p>
             <a:pPr algn="l">
               <a:spcAft>
-                <a:spcPts val="700"/>
+                <a:spcPts val="400"/>
               </a:spcAft>
             </a:pPr>
             <a:r>
-              <a:rPr sz="1400" b="0" i="0">
+              <a:rPr sz="1300" b="0" i="0">
                 <a:solidFill>
-                  <a:srgbClr val="C9D3DA"/>
+                  <a:srgbClr val="1B2433"/>
                 </a:solidFill>
                 <a:latin typeface="Calibri"/>
               </a:rPr>
               <a:t>Layers needed grow with N, and vary a lot between puzzles of the same size.</a:t>
             </a:r>
           </a:p>
+        </p:txBody>
+      </p:sp>
+      <p:sp>
+        <p:nvSpPr>
+          <p:cNvPr id="13" name="Rounded Rectangle 12"/>
+          <p:cNvSpPr/>
+          <p:nvPr/>
+        </p:nvSpPr>
+        <p:spPr>
+          <a:xfrm>
+            <a:off x="6949440" y="3703320"/>
+            <a:ext cx="4754880" cy="1508760"/>
+          </a:xfrm>
+          <a:prstGeom prst="roundRect">
+            <a:avLst>
+              <a:gd name="adj" fmla="val 6000"/>
+            </a:avLst>
+          </a:prstGeom>
+          <a:solidFill>
+            <a:srgbClr val="E8F4F3"/>
+          </a:solidFill>
+          <a:ln>
+            <a:noFill/>
+          </a:ln>
+        </p:spPr>
+        <p:style>
+          <a:lnRef idx="1">
+            <a:schemeClr val="accent1"/>
+          </a:lnRef>
+          <a:fillRef idx="3">
+            <a:schemeClr val="accent1"/>
+          </a:fillRef>
+          <a:effectRef idx="2">
+            <a:schemeClr val="accent1"/>
+          </a:effectRef>
+          <a:fontRef idx="minor">
+            <a:schemeClr val="lt1"/>
+          </a:fontRef>
+        </p:style>
+        <p:txBody>
+          <a:bodyPr rtlCol="0" anchor="ctr"/>
+          <a:lstStyle/>
+          <a:p>
+            <a:pPr algn="ctr"/>
+          </a:p>
+        </p:txBody>
+      </p:sp>
+      <p:sp>
+        <p:nvSpPr>
+          <p:cNvPr id="14" name="TextBox 13"/>
+          <p:cNvSpPr txBox="1"/>
+          <p:nvPr/>
+        </p:nvSpPr>
+        <p:spPr>
+          <a:xfrm>
+            <a:off x="7178040" y="3794760"/>
+            <a:ext cx="4389120" cy="1371600"/>
+          </a:xfrm>
+          <a:prstGeom prst="rect">
+            <a:avLst/>
+          </a:prstGeom>
+          <a:noFill/>
+        </p:spPr>
+        <p:txBody>
+          <a:bodyPr wrap="square" anchor="t" lIns="0" rIns="0">
+            <a:spAutoFit/>
+          </a:bodyPr>
+          <a:lstStyle/>
           <a:p>
             <a:pPr algn="l">
               <a:spcAft>
-                <a:spcPts val="700"/>
+                <a:spcPts val="400"/>
               </a:spcAft>
             </a:pPr>
             <a:r>
-              <a:rPr sz="1900" b="1" i="0">
+              <a:rPr sz="1700" b="1" i="0">
                 <a:solidFill>
-                  <a:srgbClr val="F0B070"/>
+                  <a:srgbClr val="C2772A"/>
                 </a:solidFill>
                 <a:latin typeface="Cambria"/>
               </a:rPr>
@@ -11807,79 +11927,95 @@
           <a:p>
             <a:pPr algn="l">
               <a:spcAft>
-                <a:spcPts val="700"/>
+                <a:spcPts val="400"/>
               </a:spcAft>
             </a:pPr>
             <a:r>
-              <a:rPr sz="1400" b="0" i="0">
+              <a:rPr sz="1300" b="0" i="0">
                 <a:solidFill>
-                  <a:srgbClr val="C9D3DA"/>
+                  <a:srgbClr val="1B2433"/>
                 </a:solidFill>
                 <a:latin typeface="Calibri"/>
               </a:rPr>
               <a:t>A smart classical solver finds the 8-cube tower in 13 ms. </a:t>
             </a:r>
             <a:r>
-              <a:rPr sz="1400" b="0" i="0">
+              <a:rPr sz="1300" b="0" i="0">
                 <a:solidFill>
-                  <a:srgbClr val="C9D3DA"/>
+                  <a:srgbClr val="1B2433"/>
                 </a:solidFill>
                 <a:latin typeface="Calibri"/>
               </a:rPr>
               <a:t>QAOA would need about 65,000 CNOTs per shot at 50%, </a:t>
             </a:r>
             <a:r>
-              <a:rPr sz="1400" b="0" i="0">
+              <a:rPr sz="1300" b="0" i="0">
                 <a:solidFill>
-                  <a:srgbClr val="C9D3DA"/>
+                  <a:srgbClr val="1B2433"/>
                 </a:solidFill>
                 <a:latin typeface="Calibri"/>
               </a:rPr>
               <a:t>plus thousands of runs to tune: far beyond today's hardware.</a:t>
             </a:r>
           </a:p>
+        </p:txBody>
+      </p:sp>
+      <p:sp>
+        <p:nvSpPr>
+          <p:cNvPr id="15" name="TextBox 14"/>
+          <p:cNvSpPr txBox="1"/>
+          <p:nvPr/>
+        </p:nvSpPr>
+        <p:spPr>
+          <a:xfrm>
+            <a:off x="6949440" y="5349240"/>
+            <a:ext cx="4754880" cy="1371600"/>
+          </a:xfrm>
+          <a:prstGeom prst="rect">
+            <a:avLst/>
+          </a:prstGeom>
+          <a:noFill/>
+        </p:spPr>
+        <p:txBody>
+          <a:bodyPr wrap="square" anchor="t" lIns="0" rIns="0">
+            <a:spAutoFit/>
+          </a:bodyPr>
+          <a:lstStyle/>
           <a:p>
             <a:pPr algn="l">
               <a:spcAft>
-                <a:spcPts val="700"/>
+                <a:spcPts val="600"/>
               </a:spcAft>
             </a:pPr>
             <a:r>
-              <a:rPr sz="1900" b="1" i="0">
+              <a:rPr sz="1300" b="1" i="0">
                 <a:solidFill>
-                  <a:srgbClr val="FFFFFF"/>
-                </a:solidFill>
-                <a:latin typeface="Cambria"/>
-              </a:rPr>
-              <a:t>Next step</a:t>
-            </a:r>
-          </a:p>
-          <a:p>
-            <a:pPr algn="l">
-              <a:spcAft>
-                <a:spcPts val="700"/>
-              </a:spcAft>
-            </a:pPr>
-            <a:r>
-              <a:rPr sz="1400" b="0" i="0">
-                <a:solidFill>
-                  <a:srgbClr val="C9D3DA"/>
+                  <a:srgbClr val="0E9488"/>
                 </a:solidFill>
                 <a:latin typeface="Calibri"/>
               </a:rPr>
-              <a:t>Track how layers grow at larger N, with CVaR (tune for the best shots, not the average).</a:t>
+              <a:t>Next step: </a:t>
+            </a:r>
+            <a:r>
+              <a:rPr sz="1300" b="0" i="0">
+                <a:solidFill>
+                  <a:srgbClr val="1B2433"/>
+                </a:solidFill>
+                <a:latin typeface="Calibri"/>
+              </a:rPr>
+              <a:t>track how layers grow at larger N, with CVaR (tune for the best shots, not the average).</a:t>
             </a:r>
           </a:p>
           <a:p>
             <a:pPr algn="l">
               <a:spcAft>
-                <a:spcPts val="700"/>
+                <a:spcPts val="600"/>
               </a:spcAft>
             </a:pPr>
             <a:r>
-              <a:rPr sz="1200" b="0" i="1">
+              <a:rPr sz="1100" b="0" i="1">
                 <a:solidFill>
-                  <a:srgbClr val="C9D3DA"/>
+                  <a:srgbClr val="5B6575"/>
                 </a:solidFill>
                 <a:latin typeface="Calibri"/>
               </a:rPr>

</xml_diff>

<commit_message>
Slide 7: add the textbook classical graph method next to QAOA and random guessing
Co-Authored-By: Claude Opus 5.5 <noreply@anthropic.com>
</commit_message>
<xml_diff>
--- a/slides.pptx
+++ b/slides.pptx
@@ -377,7 +377,7 @@
               <c:strCache>
                 <c:ptCount val="1"/>
                 <c:pt idx="0">
-                  <c:v>QAOA p = 10</c:v>
+                  <c:v>classical graph method</c:v>
                 </c:pt>
               </c:strCache>
             </c:strRef>
@@ -385,7 +385,7 @@
           <c:spPr>
             <a:ln w="31750">
               <a:solidFill>
-                <a:srgbClr val="0E9488"/>
+                <a:srgbClr val="C2772A"/>
               </a:solidFill>
             </a:ln>
           </c:spPr>
@@ -393,8 +393,13 @@
             <c:symbol val="circle"/>
             <c:spPr>
               <a:solidFill>
-                <a:srgbClr val="0E9488"/>
+                <a:srgbClr val="C2772A"/>
               </a:solidFill>
+              <a:ln>
+                <a:solidFill>
+                  <a:srgbClr val="C2772A"/>
+                </a:solidFill>
+              </a:ln>
             </c:spPr>
           </c:marker>
           <c:cat>
@@ -427,19 +432,19 @@
                 <c:formatCode>General</c:formatCode>
                 <c:ptCount val="5"/>
                 <c:pt idx="0">
-                  <c:v>0.5787952599097943</c:v>
+                  <c:v>1.0</c:v>
                 </c:pt>
                 <c:pt idx="1">
-                  <c:v>0.09108621479612343</c:v>
+                  <c:v>1.0</c:v>
                 </c:pt>
                 <c:pt idx="2">
-                  <c:v>0.09456350094970882</c:v>
+                  <c:v>1.0</c:v>
                 </c:pt>
                 <c:pt idx="3">
-                  <c:v>0.03484286082799597</c:v>
+                  <c:v>1.0</c:v>
                 </c:pt>
                 <c:pt idx="4">
-                  <c:v>0.042934894629718424</c:v>
+                  <c:v>1.0</c:v>
                 </c:pt>
               </c:numCache>
             </c:numRef>
@@ -455,7 +460,7 @@
               <c:strCache>
                 <c:ptCount val="1"/>
                 <c:pt idx="0">
-                  <c:v>random legal guess</c:v>
+                  <c:v>QAOA p = 10</c:v>
                 </c:pt>
               </c:strCache>
             </c:strRef>
@@ -463,7 +468,7 @@
           <c:spPr>
             <a:ln w="31750">
               <a:solidFill>
-                <a:srgbClr val="5B6575"/>
+                <a:srgbClr val="0E9488"/>
               </a:solidFill>
             </a:ln>
           </c:spPr>
@@ -471,8 +476,13 @@
             <c:symbol val="circle"/>
             <c:spPr>
               <a:solidFill>
-                <a:srgbClr val="5B6575"/>
+                <a:srgbClr val="0E9488"/>
               </a:solidFill>
+              <a:ln>
+                <a:solidFill>
+                  <a:srgbClr val="0E9488"/>
+                </a:solidFill>
+              </a:ln>
             </c:spPr>
           </c:marker>
           <c:cat>
@@ -501,6 +511,89 @@
           <c:val>
             <c:numRef>
               <c:f>Sheet1!$C$2:$C$6</c:f>
+              <c:numCache>
+                <c:formatCode>General</c:formatCode>
+                <c:ptCount val="5"/>
+                <c:pt idx="0">
+                  <c:v>0.5787952599097943</c:v>
+                </c:pt>
+                <c:pt idx="1">
+                  <c:v>0.09108621479612343</c:v>
+                </c:pt>
+                <c:pt idx="2">
+                  <c:v>0.09456350094970882</c:v>
+                </c:pt>
+                <c:pt idx="3">
+                  <c:v>0.03484286082799597</c:v>
+                </c:pt>
+                <c:pt idx="4">
+                  <c:v>0.042934894629718424</c:v>
+                </c:pt>
+              </c:numCache>
+            </c:numRef>
+          </c:val>
+          <c:smooth val="0"/>
+        </c:ser>
+        <c:ser>
+          <c:idx val="2"/>
+          <c:order val="2"/>
+          <c:tx>
+            <c:strRef>
+              <c:f>Sheet1!$D$1</c:f>
+              <c:strCache>
+                <c:ptCount val="1"/>
+                <c:pt idx="0">
+                  <c:v>random legal guess</c:v>
+                </c:pt>
+              </c:strCache>
+            </c:strRef>
+          </c:tx>
+          <c:spPr>
+            <a:ln w="31750">
+              <a:solidFill>
+                <a:srgbClr val="5B6575"/>
+              </a:solidFill>
+            </a:ln>
+          </c:spPr>
+          <c:marker>
+            <c:symbol val="circle"/>
+            <c:spPr>
+              <a:solidFill>
+                <a:srgbClr val="5B6575"/>
+              </a:solidFill>
+              <a:ln>
+                <a:solidFill>
+                  <a:srgbClr val="5B6575"/>
+                </a:solidFill>
+              </a:ln>
+            </c:spPr>
+          </c:marker>
+          <c:cat>
+            <c:strRef>
+              <c:f>Sheet1!$A$2:$A$6</c:f>
+              <c:strCache>
+                <c:ptCount val="5"/>
+                <c:pt idx="0">
+                  <c:v>4</c:v>
+                </c:pt>
+                <c:pt idx="1">
+                  <c:v>5</c:v>
+                </c:pt>
+                <c:pt idx="2">
+                  <c:v>6</c:v>
+                </c:pt>
+                <c:pt idx="3">
+                  <c:v>7</c:v>
+                </c:pt>
+                <c:pt idx="4">
+                  <c:v>8</c:v>
+                </c:pt>
+              </c:strCache>
+            </c:strRef>
+          </c:cat>
+          <c:val>
+            <c:numRef>
+              <c:f>Sheet1!$D$2:$D$6</c:f>
               <c:numCache>
                 <c:formatCode>General</c:formatCode>
                 <c:ptCount val="5"/>
@@ -686,10 +779,10 @@
           </c:marker>
           <c:xVal>
             <c:numRef>
-              <c:f>Sheet1!$A$2:$A$14</c:f>
+              <c:f>Sheet1!$A$2:$A$17</c:f>
               <c:numCache>
                 <c:formatCode>General</c:formatCode>
-                <c:ptCount val="13"/>
+                <c:ptCount val="16"/>
                 <c:pt idx="0">
                   <c:v>4</c:v>
                 </c:pt>
@@ -727,6 +820,15 @@
                   <c:v>7</c:v>
                 </c:pt>
                 <c:pt idx="12">
+                  <c:v>7</c:v>
+                </c:pt>
+                <c:pt idx="13">
+                  <c:v>7</c:v>
+                </c:pt>
+                <c:pt idx="14">
+                  <c:v>7</c:v>
+                </c:pt>
+                <c:pt idx="15">
                   <c:v>8</c:v>
                 </c:pt>
               </c:numCache>
@@ -734,10 +836,10 @@
           </c:xVal>
           <c:yVal>
             <c:numRef>
-              <c:f>Sheet1!$B$2:$B$14</c:f>
+              <c:f>Sheet1!$B$2:$B$17</c:f>
               <c:numCache>
                 <c:formatCode>General</c:formatCode>
-                <c:ptCount val="13"/>
+                <c:ptCount val="16"/>
                 <c:pt idx="0">
                   <c:v>9</c:v>
                 </c:pt>
@@ -775,6 +877,15 @@
                   <c:v>33</c:v>
                 </c:pt>
                 <c:pt idx="12">
+                  <c:v>28</c:v>
+                </c:pt>
+                <c:pt idx="13">
+                  <c:v>23</c:v>
+                </c:pt>
+                <c:pt idx="14">
+                  <c:v>23</c:v>
+                </c:pt>
+                <c:pt idx="15">
                   <c:v>31</c:v>
                 </c:pt>
               </c:numCache>
@@ -787,7 +898,7 @@
           <c:order val="1"/>
           <c:tx>
             <c:strRef>
-              <c:f>Sheet1!$B$16</c:f>
+              <c:f>Sheet1!$B$19</c:f>
               <c:strCache>
                 <c:ptCount val="1"/>
                 <c:pt idx="0">
@@ -814,7 +925,7 @@
           </c:marker>
           <c:xVal>
             <c:numRef>
-              <c:f>Sheet1!$A$17:$A$21</c:f>
+              <c:f>Sheet1!$A$20:$A$24</c:f>
               <c:numCache>
                 <c:formatCode>General</c:formatCode>
                 <c:ptCount val="5"/>
@@ -838,7 +949,7 @@
           </c:xVal>
           <c:yVal>
             <c:numRef>
-              <c:f>Sheet1!$B$17:$B$21</c:f>
+              <c:f>Sheet1!$B$20:$B$24</c:f>
               <c:numCache>
                 <c:formatCode>General</c:formatCode>
                 <c:ptCount val="5"/>
@@ -852,7 +963,7 @@
                   <c:v>24</c:v>
                 </c:pt>
                 <c:pt idx="3">
-                  <c:v>33</c:v>
+                  <c:v>25.5</c:v>
                 </c:pt>
                 <c:pt idx="4">
                   <c:v>31</c:v>
@@ -10395,7 +10506,7 @@
                 </a:solidFill>
                 <a:latin typeface="Cambria"/>
               </a:rPr>
-              <a:t>Bonus: same method for N cubes and N colours</a:t>
+              <a:t>Bonus: same method for N cubes and N colors</a:t>
             </a:r>
           </a:p>
         </p:txBody>
@@ -11299,8 +11410,8 @@
         </p:nvSpPr>
         <p:spPr>
           <a:xfrm>
-            <a:off x="7040880" y="4709160"/>
-            <a:ext cx="4663440" cy="1554480"/>
+            <a:off x="7040880" y="4663440"/>
+            <a:ext cx="4663440" cy="1737360"/>
           </a:xfrm>
           <a:prstGeom prst="rect">
             <a:avLst/>
@@ -11319,13 +11430,22 @@
               </a:spcAft>
             </a:pPr>
             <a:r>
-              <a:rPr sz="1400" b="0" i="0">
+              <a:rPr sz="1300" b="1" i="0">
                 <a:solidFill>
                   <a:srgbClr val="1B2433"/>
                 </a:solidFill>
                 <a:latin typeface="Calibri"/>
               </a:rPr>
-              <a:t>Qubits grow as 3N; CNOTs per layer grow about linearly here (550 → 2,100).</a:t>
+              <a:t>Beats guessing, loses to classical. </a:t>
+            </a:r>
+            <a:r>
+              <a:rPr sz="1300" b="0" i="0">
+                <a:solidFill>
+                  <a:srgbClr val="1B2433"/>
+                </a:solidFill>
+                <a:latin typeface="Calibri"/>
+              </a:rPr>
+              <a:t>At fixed depth our success falls with N, but more slowly than random guessing, so the gap over guessing grows.</a:t>
             </a:r>
           </a:p>
           <a:p>
@@ -11335,13 +11455,22 @@
               </a:spcAft>
             </a:pPr>
             <a:r>
-              <a:rPr sz="1400" b="0" i="0">
+              <a:rPr sz="1300" b="1" i="0">
+                <a:solidFill>
+                  <a:srgbClr val="C2772A"/>
+                </a:solidFill>
+                <a:latin typeface="Calibri"/>
+              </a:rPr>
+              <a:t>The textbook classical method </a:t>
+            </a:r>
+            <a:r>
+              <a:rPr sz="1300" b="0" i="0">
                 <a:solidFill>
                   <a:srgbClr val="1B2433"/>
                 </a:solidFill>
                 <a:latin typeface="Calibri"/>
               </a:rPr>
-              <a:t>At fixed depth success falls with N, but more slowly than random guessing: the advantage over guessing grows. Keeping success high would need more layers.</a:t>
+              <a:t>(the same color graph) always finds the tower, in 13 ms at N = 8.</a:t>
             </a:r>
           </a:p>
         </p:txBody>
@@ -11705,7 +11834,7 @@
                 </a:solidFill>
                 <a:latin typeface="Calibri"/>
               </a:rPr>
-              <a:t>13 puzzles, exact simulation, angles tuned on the average cost only. Puzzles of the same size differ a lot, so one puzzle per size is not enough.</a:t>
+              <a:t>16 puzzles, exact simulation, angles tuned on the average cost only. Puzzles of the same size differ a lot, so one puzzle per size is not enough.</a:t>
             </a:r>
           </a:p>
         </p:txBody>

</xml_diff>